<commit_message>
feat(project-05): finalize 100% complete implementation, models, tests, docs, PPT, and video demonstration for PROJECT-005
</commit_message>
<xml_diff>
--- a/project_05_career_guidance/presentations/project_presentation.pptx
+++ b/project_05_career_guidance/presentations/project_presentation.pptx
@@ -13,6 +13,13 @@
     <p:sldId id="261" r:id="rId12"/>
     <p:sldId id="262" r:id="rId13"/>
     <p:sldId id="263" r:id="rId14"/>
+    <p:sldId id="264" r:id="rId15"/>
+    <p:sldId id="265" r:id="rId16"/>
+    <p:sldId id="266" r:id="rId17"/>
+    <p:sldId id="267" r:id="rId18"/>
+    <p:sldId id="268" r:id="rId19"/>
+    <p:sldId id="269" r:id="rId20"/>
+    <p:sldId id="270" r:id="rId21"/>
   </p:sldIdLst>
   <p:sldSz cx="12191695" cy="6858000" type="screen4x3"/>
   <p:notesSz cx="6858000" cy="9144000"/>
@@ -3146,8 +3153,8 @@
         </p:nvSpPr>
         <p:spPr>
           <a:xfrm>
-            <a:off x="1097280" y="1645920"/>
-            <a:ext cx="10058400" cy="3474720"/>
+            <a:off x="914400" y="1828800"/>
+            <a:ext cx="10362895" cy="3200400"/>
           </a:xfrm>
           <a:prstGeom prst="rect">
             <a:avLst/>
@@ -3161,44 +3168,1295 @@
           <a:lstStyle/>
           <a:p>
             <a:pPr>
-              <a:defRPr sz="1400" b="1">
-                <a:solidFill>
-                  <a:srgbClr val="38BDF8"/>
-                </a:solidFill>
-              </a:defRPr>
-            </a:pPr>
-            <a:r>
-              <a:t>PROJECT 05 OF 55  •  RESEARCH &amp; IMPLEMENTATION DECK</a:t>
-            </a:r>
-          </a:p>
-          <a:p>
-            <a:pPr>
-              <a:spcBef>
-                <a:spcPts val="1400"/>
-              </a:spcBef>
+              <a:defRPr sz="1300" b="1">
+                <a:solidFill>
+                  <a:srgbClr val="6366F1"/>
+                </a:solidFill>
+              </a:defRPr>
+            </a:pPr>
+            <a:r>
+              <a:t>PROJECT 05 OF 55 • AI-ASSISTED CAREER GUIDANCE</a:t>
+            </a:r>
+          </a:p>
+          <a:p>
+            <a:pPr>
               <a:defRPr sz="3200" b="1">
                 <a:solidFill>
-                  <a:srgbClr val="FFFFFF"/>
-                </a:solidFill>
-              </a:defRPr>
-            </a:pPr>
-            <a:r>
-              <a:t>CAREER GUIDANCE APP FOR STUDENTS - AI ASSISTED</a:t>
-            </a:r>
-          </a:p>
-          <a:p>
-            <a:pPr>
-              <a:spcBef>
-                <a:spcPts val="1200"/>
-              </a:spcBef>
+                  <a:srgbClr val="F8FAFC"/>
+                </a:solidFill>
+              </a:defRPr>
+            </a:pPr>
+            <a:r>
+              <a:t>Career Guidance System for Students Using Machine Learning</a:t>
+            </a:r>
+          </a:p>
+          <a:p>
+            <a:pPr>
               <a:defRPr sz="1600">
                 <a:solidFill>
-                  <a:srgbClr val="CBD5E1"/>
-                </a:solidFill>
-              </a:defRPr>
-            </a:pPr>
-            <a:r>
-              <a:t>Enterprise-Grade AI Architecture, Machine Learning Pipeline &amp; Deployment Framework</a:t>
+                  <a:srgbClr val="94A3B8"/>
+                </a:solidFill>
+              </a:defRPr>
+            </a:pPr>
+            <a:r>
+              <a:t>Multi-Class Job Role Classification, Cognitive Aptitude Mapping, and Tailored Industry Roadmaps</a:t>
+            </a:r>
+          </a:p>
+          <a:p>
+            <a:br/>
+            <a:pPr>
+              <a:defRPr sz="1200">
+                <a:solidFill>
+                  <a:srgbClr val="10B981"/>
+                </a:solidFill>
+              </a:defRPr>
+            </a:pPr>
+            <a:r>
+              <a:t>Department of Computer Science &amp; Engineering • Final Year Engineering Capstone</a:t>
+            </a:r>
+          </a:p>
+        </p:txBody>
+      </p:sp>
+    </p:spTree>
+  </p:cSld>
+  <p:clrMapOvr>
+    <a:masterClrMapping/>
+  </p:clrMapOvr>
+</p:sld>
+</file>
+
+<file path=ppt/slides/slide10.xml><?xml version="1.0" encoding="utf-8"?>
+<p:sld xmlns:a="http://schemas.openxmlformats.org/drawingml/2006/main" xmlns:p="http://schemas.openxmlformats.org/presentationml/2006/main" xmlns:r="http://schemas.openxmlformats.org/officeDocument/2006/relationships">
+  <p:cSld>
+    <p:spTree>
+      <p:nvGrpSpPr>
+        <p:cNvPr id="1" name=""/>
+        <p:cNvGrpSpPr/>
+        <p:nvPr/>
+      </p:nvGrpSpPr>
+      <p:grpSpPr/>
+      <p:sp>
+        <p:nvSpPr>
+          <p:cNvPr id="2" name="Rectangle 1"/>
+          <p:cNvSpPr/>
+          <p:nvPr/>
+        </p:nvSpPr>
+        <p:spPr>
+          <a:xfrm>
+            <a:off x="0" y="0"/>
+            <a:ext cx="12191695" cy="6858000"/>
+          </a:xfrm>
+          <a:prstGeom prst="rect">
+            <a:avLst/>
+          </a:prstGeom>
+          <a:solidFill>
+            <a:srgbClr val="0F172A"/>
+          </a:solidFill>
+          <a:ln>
+            <a:noFill/>
+          </a:ln>
+        </p:spPr>
+        <p:style>
+          <a:lnRef idx="1">
+            <a:schemeClr val="accent1"/>
+          </a:lnRef>
+          <a:fillRef idx="3">
+            <a:schemeClr val="accent1"/>
+          </a:fillRef>
+          <a:effectRef idx="2">
+            <a:schemeClr val="accent1"/>
+          </a:effectRef>
+          <a:fontRef idx="minor">
+            <a:schemeClr val="lt1"/>
+          </a:fontRef>
+        </p:style>
+        <p:txBody>
+          <a:bodyPr rtlCol="0" anchor="ctr"/>
+          <a:lstStyle/>
+          <a:p>
+            <a:pPr algn="ctr"/>
+          </a:p>
+        </p:txBody>
+      </p:sp>
+      <p:sp>
+        <p:nvSpPr>
+          <p:cNvPr id="3" name="TextBox 2"/>
+          <p:cNvSpPr txBox="1"/>
+          <p:nvPr/>
+        </p:nvSpPr>
+        <p:spPr>
+          <a:xfrm>
+            <a:off x="731520" y="457200"/>
+            <a:ext cx="10728655" cy="1005840"/>
+          </a:xfrm>
+          <a:prstGeom prst="rect">
+            <a:avLst/>
+          </a:prstGeom>
+          <a:noFill/>
+        </p:spPr>
+        <p:txBody>
+          <a:bodyPr wrap="square">
+            <a:spAutoFit/>
+          </a:bodyPr>
+          <a:lstStyle/>
+          <a:p>
+            <a:pPr>
+              <a:defRPr sz="1100" b="1">
+                <a:solidFill>
+                  <a:srgbClr val="6366F1"/>
+                </a:solidFill>
+              </a:defRPr>
+            </a:pPr>
+            <a:r>
+              <a:t>STUDENT CAREER INTELLIGENCE &amp; APPLIED MACHINE LEARNING</a:t>
+            </a:r>
+          </a:p>
+          <a:p>
+            <a:pPr>
+              <a:defRPr sz="2200" b="1">
+                <a:solidFill>
+                  <a:srgbClr val="F8FAFC"/>
+                </a:solidFill>
+              </a:defRPr>
+            </a:pPr>
+            <a:r>
+              <a:t>Student Assessment Portal &amp; Preset Profiles</a:t>
+            </a:r>
+          </a:p>
+        </p:txBody>
+      </p:sp>
+      <p:pic>
+        <p:nvPicPr>
+          <p:cNvPr id="4" name="Picture 3" descr="01_landing_student_assessment.png"/>
+          <p:cNvPicPr>
+            <a:picLocks noChangeAspect="1"/>
+          </p:cNvPicPr>
+          <p:nvPr/>
+        </p:nvPicPr>
+        <p:blipFill>
+          <a:blip r:embed="rId2"/>
+          <a:stretch>
+            <a:fillRect/>
+          </a:stretch>
+        </p:blipFill>
+        <p:spPr>
+          <a:xfrm>
+            <a:off x="731520" y="1645920"/>
+            <a:ext cx="7772400" cy="4857750"/>
+          </a:xfrm>
+          <a:prstGeom prst="rect">
+            <a:avLst/>
+          </a:prstGeom>
+        </p:spPr>
+      </p:pic>
+      <p:sp>
+        <p:nvSpPr>
+          <p:cNvPr id="5" name="TextBox 4"/>
+          <p:cNvSpPr txBox="1"/>
+          <p:nvPr/>
+        </p:nvSpPr>
+        <p:spPr>
+          <a:xfrm>
+            <a:off x="8778240" y="1645920"/>
+            <a:ext cx="2743200" cy="4572000"/>
+          </a:xfrm>
+          <a:prstGeom prst="rect">
+            <a:avLst/>
+          </a:prstGeom>
+          <a:noFill/>
+        </p:spPr>
+        <p:txBody>
+          <a:bodyPr wrap="square">
+            <a:spAutoFit/>
+          </a:bodyPr>
+          <a:lstStyle/>
+          <a:p>
+            <a:pPr>
+              <a:defRPr b="1" sz="1400">
+                <a:solidFill>
+                  <a:srgbClr val="6366F1"/>
+                </a:solidFill>
+              </a:defRPr>
+            </a:pPr>
+            <a:r>
+              <a:t>Dashboard Features:</a:t>
+            </a:r>
+          </a:p>
+          <a:p>
+            <a:pPr>
+              <a:defRPr sz="1100">
+                <a:solidFill>
+                  <a:srgbClr val="F8FAFC"/>
+                </a:solidFill>
+              </a:defRPr>
+            </a:pPr>
+            <a:r>
+              <a:t>• Live Engine Status: Flask microservice operating on port 5005.</a:t>
+            </a:r>
+          </a:p>
+          <a:p>
+            <a:pPr>
+              <a:defRPr sz="1100">
+                <a:solidFill>
+                  <a:srgbClr val="F8FAFC"/>
+                </a:solidFill>
+              </a:defRPr>
+            </a:pPr>
+            <a:r>
+              <a:t>• Model Selector: Allows switching between XGBoost, Random Forest, and Decision Tree.</a:t>
+            </a:r>
+          </a:p>
+          <a:p>
+            <a:pPr>
+              <a:defRPr sz="1100">
+                <a:solidFill>
+                  <a:srgbClr val="F8FAFC"/>
+                </a:solidFill>
+              </a:defRPr>
+            </a:pPr>
+            <a:r>
+              <a:t>• Candidate Name Input: Personalized student identity logging.</a:t>
+            </a:r>
+          </a:p>
+          <a:p>
+            <a:pPr>
+              <a:defRPr sz="1100">
+                <a:solidFill>
+                  <a:srgbClr val="F8FAFC"/>
+                </a:solidFill>
+              </a:defRPr>
+            </a:pPr>
+            <a:r>
+              <a:t>• Instant Preset Pills: 5 pre-configured student aptitude personas for rapid evaluation.</a:t>
+            </a:r>
+          </a:p>
+        </p:txBody>
+      </p:sp>
+    </p:spTree>
+  </p:cSld>
+  <p:clrMapOvr>
+    <a:masterClrMapping/>
+  </p:clrMapOvr>
+</p:sld>
+</file>
+
+<file path=ppt/slides/slide11.xml><?xml version="1.0" encoding="utf-8"?>
+<p:sld xmlns:a="http://schemas.openxmlformats.org/drawingml/2006/main" xmlns:p="http://schemas.openxmlformats.org/presentationml/2006/main" xmlns:r="http://schemas.openxmlformats.org/officeDocument/2006/relationships">
+  <p:cSld>
+    <p:spTree>
+      <p:nvGrpSpPr>
+        <p:cNvPr id="1" name=""/>
+        <p:cNvGrpSpPr/>
+        <p:nvPr/>
+      </p:nvGrpSpPr>
+      <p:grpSpPr/>
+      <p:sp>
+        <p:nvSpPr>
+          <p:cNvPr id="2" name="Rectangle 1"/>
+          <p:cNvSpPr/>
+          <p:nvPr/>
+        </p:nvSpPr>
+        <p:spPr>
+          <a:xfrm>
+            <a:off x="0" y="0"/>
+            <a:ext cx="12191695" cy="6858000"/>
+          </a:xfrm>
+          <a:prstGeom prst="rect">
+            <a:avLst/>
+          </a:prstGeom>
+          <a:solidFill>
+            <a:srgbClr val="0F172A"/>
+          </a:solidFill>
+          <a:ln>
+            <a:noFill/>
+          </a:ln>
+        </p:spPr>
+        <p:style>
+          <a:lnRef idx="1">
+            <a:schemeClr val="accent1"/>
+          </a:lnRef>
+          <a:fillRef idx="3">
+            <a:schemeClr val="accent1"/>
+          </a:fillRef>
+          <a:effectRef idx="2">
+            <a:schemeClr val="accent1"/>
+          </a:effectRef>
+          <a:fontRef idx="minor">
+            <a:schemeClr val="lt1"/>
+          </a:fontRef>
+        </p:style>
+        <p:txBody>
+          <a:bodyPr rtlCol="0" anchor="ctr"/>
+          <a:lstStyle/>
+          <a:p>
+            <a:pPr algn="ctr"/>
+          </a:p>
+        </p:txBody>
+      </p:sp>
+      <p:sp>
+        <p:nvSpPr>
+          <p:cNvPr id="3" name="TextBox 2"/>
+          <p:cNvSpPr txBox="1"/>
+          <p:nvPr/>
+        </p:nvSpPr>
+        <p:spPr>
+          <a:xfrm>
+            <a:off x="731520" y="457200"/>
+            <a:ext cx="10728655" cy="1005840"/>
+          </a:xfrm>
+          <a:prstGeom prst="rect">
+            <a:avLst/>
+          </a:prstGeom>
+          <a:noFill/>
+        </p:spPr>
+        <p:txBody>
+          <a:bodyPr wrap="square">
+            <a:spAutoFit/>
+          </a:bodyPr>
+          <a:lstStyle/>
+          <a:p>
+            <a:pPr>
+              <a:defRPr sz="1100" b="1">
+                <a:solidFill>
+                  <a:srgbClr val="6366F1"/>
+                </a:solidFill>
+              </a:defRPr>
+            </a:pPr>
+            <a:r>
+              <a:t>STUDENT CAREER INTELLIGENCE &amp; APPLIED MACHINE LEARNING</a:t>
+            </a:r>
+          </a:p>
+          <a:p>
+            <a:pPr>
+              <a:defRPr sz="2200" b="1">
+                <a:solidFill>
+                  <a:srgbClr val="F8FAFC"/>
+                </a:solidFill>
+              </a:defRPr>
+            </a:pPr>
+            <a:r>
+              <a:t>Multi-Profile Career Matching Demonstrations</a:t>
+            </a:r>
+          </a:p>
+        </p:txBody>
+      </p:sp>
+      <p:pic>
+        <p:nvPicPr>
+          <p:cNvPr id="4" name="Picture 3" descr="02_fullstack_developer_recommendation.png"/>
+          <p:cNvPicPr>
+            <a:picLocks noChangeAspect="1"/>
+          </p:cNvPicPr>
+          <p:nvPr/>
+        </p:nvPicPr>
+        <p:blipFill>
+          <a:blip r:embed="rId2"/>
+          <a:stretch>
+            <a:fillRect/>
+          </a:stretch>
+        </p:blipFill>
+        <p:spPr>
+          <a:xfrm>
+            <a:off x="731520" y="1645920"/>
+            <a:ext cx="5212080" cy="3257550"/>
+          </a:xfrm>
+          <a:prstGeom prst="rect">
+            <a:avLst/>
+          </a:prstGeom>
+        </p:spPr>
+      </p:pic>
+      <p:pic>
+        <p:nvPicPr>
+          <p:cNvPr id="5" name="Picture 4" descr="03_cybersecurity_network_recommendation.png"/>
+          <p:cNvPicPr>
+            <a:picLocks noChangeAspect="1"/>
+          </p:cNvPicPr>
+          <p:nvPr/>
+        </p:nvPicPr>
+        <p:blipFill>
+          <a:blip r:embed="rId3"/>
+          <a:stretch>
+            <a:fillRect/>
+          </a:stretch>
+        </p:blipFill>
+        <p:spPr>
+          <a:xfrm>
+            <a:off x="6217920" y="1645920"/>
+            <a:ext cx="5212080" cy="3257550"/>
+          </a:xfrm>
+          <a:prstGeom prst="rect">
+            <a:avLst/>
+          </a:prstGeom>
+        </p:spPr>
+      </p:pic>
+      <p:sp>
+        <p:nvSpPr>
+          <p:cNvPr id="6" name="TextBox 5"/>
+          <p:cNvSpPr txBox="1"/>
+          <p:nvPr/>
+        </p:nvSpPr>
+        <p:spPr>
+          <a:xfrm>
+            <a:off x="731520" y="5303520"/>
+            <a:ext cx="10728655" cy="1188720"/>
+          </a:xfrm>
+          <a:prstGeom prst="rect">
+            <a:avLst/>
+          </a:prstGeom>
+          <a:noFill/>
+        </p:spPr>
+        <p:txBody>
+          <a:bodyPr wrap="square">
+            <a:spAutoFit/>
+          </a:bodyPr>
+          <a:lstStyle/>
+          <a:p>
+            <a:pPr>
+              <a:defRPr sz="1200">
+                <a:solidFill>
+                  <a:srgbClr val="10B981"/>
+                </a:solidFill>
+              </a:defRPr>
+            </a:pPr>
+            <a:r>
+              <a:t>Left: Full-Stack Developer profile matches Database / Software Developer roles • Right: Cybersecurity candidate matches Network Security Administrator with detailed salary and skills breakdown.</a:t>
+            </a:r>
+          </a:p>
+        </p:txBody>
+      </p:sp>
+    </p:spTree>
+  </p:cSld>
+  <p:clrMapOvr>
+    <a:masterClrMapping/>
+  </p:clrMapOvr>
+</p:sld>
+</file>
+
+<file path=ppt/slides/slide12.xml><?xml version="1.0" encoding="utf-8"?>
+<p:sld xmlns:a="http://schemas.openxmlformats.org/drawingml/2006/main" xmlns:p="http://schemas.openxmlformats.org/presentationml/2006/main" xmlns:r="http://schemas.openxmlformats.org/officeDocument/2006/relationships">
+  <p:cSld>
+    <p:spTree>
+      <p:nvGrpSpPr>
+        <p:cNvPr id="1" name=""/>
+        <p:cNvGrpSpPr/>
+        <p:nvPr/>
+      </p:nvGrpSpPr>
+      <p:grpSpPr/>
+      <p:sp>
+        <p:nvSpPr>
+          <p:cNvPr id="2" name="Rectangle 1"/>
+          <p:cNvSpPr/>
+          <p:nvPr/>
+        </p:nvSpPr>
+        <p:spPr>
+          <a:xfrm>
+            <a:off x="0" y="0"/>
+            <a:ext cx="12191695" cy="6858000"/>
+          </a:xfrm>
+          <a:prstGeom prst="rect">
+            <a:avLst/>
+          </a:prstGeom>
+          <a:solidFill>
+            <a:srgbClr val="0F172A"/>
+          </a:solidFill>
+          <a:ln>
+            <a:noFill/>
+          </a:ln>
+        </p:spPr>
+        <p:style>
+          <a:lnRef idx="1">
+            <a:schemeClr val="accent1"/>
+          </a:lnRef>
+          <a:fillRef idx="3">
+            <a:schemeClr val="accent1"/>
+          </a:fillRef>
+          <a:effectRef idx="2">
+            <a:schemeClr val="accent1"/>
+          </a:effectRef>
+          <a:fontRef idx="minor">
+            <a:schemeClr val="lt1"/>
+          </a:fontRef>
+        </p:style>
+        <p:txBody>
+          <a:bodyPr rtlCol="0" anchor="ctr"/>
+          <a:lstStyle/>
+          <a:p>
+            <a:pPr algn="ctr"/>
+          </a:p>
+        </p:txBody>
+      </p:sp>
+      <p:sp>
+        <p:nvSpPr>
+          <p:cNvPr id="3" name="TextBox 2"/>
+          <p:cNvSpPr txBox="1"/>
+          <p:nvPr/>
+        </p:nvSpPr>
+        <p:spPr>
+          <a:xfrm>
+            <a:off x="731520" y="457200"/>
+            <a:ext cx="10728655" cy="1005840"/>
+          </a:xfrm>
+          <a:prstGeom prst="rect">
+            <a:avLst/>
+          </a:prstGeom>
+          <a:noFill/>
+        </p:spPr>
+        <p:txBody>
+          <a:bodyPr wrap="square">
+            <a:spAutoFit/>
+          </a:bodyPr>
+          <a:lstStyle/>
+          <a:p>
+            <a:pPr>
+              <a:defRPr sz="1100" b="1">
+                <a:solidFill>
+                  <a:srgbClr val="6366F1"/>
+                </a:solidFill>
+              </a:defRPr>
+            </a:pPr>
+            <a:r>
+              <a:t>STUDENT CAREER INTELLIGENCE &amp; APPLIED MACHINE LEARNING</a:t>
+            </a:r>
+          </a:p>
+          <a:p>
+            <a:pPr>
+              <a:defRPr sz="2200" b="1">
+                <a:solidFill>
+                  <a:srgbClr val="F8FAFC"/>
+                </a:solidFill>
+              </a:defRPr>
+            </a:pPr>
+            <a:r>
+              <a:t>Alternative Career Pathways &amp; Domain Insights</a:t>
+            </a:r>
+          </a:p>
+        </p:txBody>
+      </p:sp>
+      <p:pic>
+        <p:nvPicPr>
+          <p:cNvPr id="4" name="Picture 3" descr="04_database_architect_recommendation.png"/>
+          <p:cNvPicPr>
+            <a:picLocks noChangeAspect="1"/>
+          </p:cNvPicPr>
+          <p:nvPr/>
+        </p:nvPicPr>
+        <p:blipFill>
+          <a:blip r:embed="rId2"/>
+          <a:stretch>
+            <a:fillRect/>
+          </a:stretch>
+        </p:blipFill>
+        <p:spPr>
+          <a:xfrm>
+            <a:off x="731520" y="1645920"/>
+            <a:ext cx="5212080" cy="3257550"/>
+          </a:xfrm>
+          <a:prstGeom prst="rect">
+            <a:avLst/>
+          </a:prstGeom>
+        </p:spPr>
+      </p:pic>
+      <p:pic>
+        <p:nvPicPr>
+          <p:cNvPr id="5" name="Picture 4" descr="05_alternative_career_pathways.png"/>
+          <p:cNvPicPr>
+            <a:picLocks noChangeAspect="1"/>
+          </p:cNvPicPr>
+          <p:nvPr/>
+        </p:nvPicPr>
+        <p:blipFill>
+          <a:blip r:embed="rId3"/>
+          <a:stretch>
+            <a:fillRect/>
+          </a:stretch>
+        </p:blipFill>
+        <p:spPr>
+          <a:xfrm>
+            <a:off x="6217920" y="1645920"/>
+            <a:ext cx="5212080" cy="3257550"/>
+          </a:xfrm>
+          <a:prstGeom prst="rect">
+            <a:avLst/>
+          </a:prstGeom>
+        </p:spPr>
+      </p:pic>
+      <p:sp>
+        <p:nvSpPr>
+          <p:cNvPr id="6" name="TextBox 5"/>
+          <p:cNvSpPr txBox="1"/>
+          <p:nvPr/>
+        </p:nvSpPr>
+        <p:spPr>
+          <a:xfrm>
+            <a:off x="731520" y="5303520"/>
+            <a:ext cx="10728655" cy="1188720"/>
+          </a:xfrm>
+          <a:prstGeom prst="rect">
+            <a:avLst/>
+          </a:prstGeom>
+          <a:noFill/>
+        </p:spPr>
+        <p:txBody>
+          <a:bodyPr wrap="square">
+            <a:spAutoFit/>
+          </a:bodyPr>
+          <a:lstStyle/>
+          <a:p>
+            <a:pPr>
+              <a:defRPr sz="1200">
+                <a:solidFill>
+                  <a:srgbClr val="6366F1"/>
+                </a:solidFill>
+              </a:defRPr>
+            </a:pPr>
+            <a:r>
+              <a:t>Left: Big Data candidate evaluation • Right: Top 3 alternative career fallback recommendations with relative confidence distribution bars.</a:t>
+            </a:r>
+          </a:p>
+        </p:txBody>
+      </p:sp>
+    </p:spTree>
+  </p:cSld>
+  <p:clrMapOvr>
+    <a:masterClrMapping/>
+  </p:clrMapOvr>
+</p:sld>
+</file>
+
+<file path=ppt/slides/slide13.xml><?xml version="1.0" encoding="utf-8"?>
+<p:sld xmlns:a="http://schemas.openxmlformats.org/drawingml/2006/main" xmlns:p="http://schemas.openxmlformats.org/presentationml/2006/main" xmlns:r="http://schemas.openxmlformats.org/officeDocument/2006/relationships">
+  <p:cSld>
+    <p:spTree>
+      <p:nvGrpSpPr>
+        <p:cNvPr id="1" name=""/>
+        <p:cNvGrpSpPr/>
+        <p:nvPr/>
+      </p:nvGrpSpPr>
+      <p:grpSpPr/>
+      <p:sp>
+        <p:nvSpPr>
+          <p:cNvPr id="2" name="Rectangle 1"/>
+          <p:cNvSpPr/>
+          <p:nvPr/>
+        </p:nvSpPr>
+        <p:spPr>
+          <a:xfrm>
+            <a:off x="0" y="0"/>
+            <a:ext cx="12191695" cy="6858000"/>
+          </a:xfrm>
+          <a:prstGeom prst="rect">
+            <a:avLst/>
+          </a:prstGeom>
+          <a:solidFill>
+            <a:srgbClr val="0F172A"/>
+          </a:solidFill>
+          <a:ln>
+            <a:noFill/>
+          </a:ln>
+        </p:spPr>
+        <p:style>
+          <a:lnRef idx="1">
+            <a:schemeClr val="accent1"/>
+          </a:lnRef>
+          <a:fillRef idx="3">
+            <a:schemeClr val="accent1"/>
+          </a:fillRef>
+          <a:effectRef idx="2">
+            <a:schemeClr val="accent1"/>
+          </a:effectRef>
+          <a:fontRef idx="minor">
+            <a:schemeClr val="lt1"/>
+          </a:fontRef>
+        </p:style>
+        <p:txBody>
+          <a:bodyPr rtlCol="0" anchor="ctr"/>
+          <a:lstStyle/>
+          <a:p>
+            <a:pPr algn="ctr"/>
+          </a:p>
+        </p:txBody>
+      </p:sp>
+      <p:sp>
+        <p:nvSpPr>
+          <p:cNvPr id="3" name="TextBox 2"/>
+          <p:cNvSpPr txBox="1"/>
+          <p:nvPr/>
+        </p:nvSpPr>
+        <p:spPr>
+          <a:xfrm>
+            <a:off x="731520" y="457200"/>
+            <a:ext cx="10728655" cy="1005840"/>
+          </a:xfrm>
+          <a:prstGeom prst="rect">
+            <a:avLst/>
+          </a:prstGeom>
+          <a:noFill/>
+        </p:spPr>
+        <p:txBody>
+          <a:bodyPr wrap="square">
+            <a:spAutoFit/>
+          </a:bodyPr>
+          <a:lstStyle/>
+          <a:p>
+            <a:pPr>
+              <a:defRPr sz="1100" b="1">
+                <a:solidFill>
+                  <a:srgbClr val="6366F1"/>
+                </a:solidFill>
+              </a:defRPr>
+            </a:pPr>
+            <a:r>
+              <a:t>STUDENT CAREER INTELLIGENCE &amp; APPLIED MACHINE LEARNING</a:t>
+            </a:r>
+          </a:p>
+          <a:p>
+            <a:pPr>
+              <a:defRPr sz="2200" b="1">
+                <a:solidFill>
+                  <a:srgbClr val="F8FAFC"/>
+                </a:solidFill>
+              </a:defRPr>
+            </a:pPr>
+            <a:r>
+              <a:t>Transactional Assessment Audit Database (SQLite)</a:t>
+            </a:r>
+          </a:p>
+        </p:txBody>
+      </p:sp>
+      <p:pic>
+        <p:nvPicPr>
+          <p:cNvPr id="4" name="Picture 3" descr="06_sqlite_assessment_history.png"/>
+          <p:cNvPicPr>
+            <a:picLocks noChangeAspect="1"/>
+          </p:cNvPicPr>
+          <p:nvPr/>
+        </p:nvPicPr>
+        <p:blipFill>
+          <a:blip r:embed="rId2"/>
+          <a:stretch>
+            <a:fillRect/>
+          </a:stretch>
+        </p:blipFill>
+        <p:spPr>
+          <a:xfrm>
+            <a:off x="731520" y="1645920"/>
+            <a:ext cx="7772400" cy="4857750"/>
+          </a:xfrm>
+          <a:prstGeom prst="rect">
+            <a:avLst/>
+          </a:prstGeom>
+        </p:spPr>
+      </p:pic>
+      <p:sp>
+        <p:nvSpPr>
+          <p:cNvPr id="5" name="TextBox 4"/>
+          <p:cNvSpPr txBox="1"/>
+          <p:nvPr/>
+        </p:nvSpPr>
+        <p:spPr>
+          <a:xfrm>
+            <a:off x="8778240" y="1645920"/>
+            <a:ext cx="2743200" cy="4572000"/>
+          </a:xfrm>
+          <a:prstGeom prst="rect">
+            <a:avLst/>
+          </a:prstGeom>
+          <a:noFill/>
+        </p:spPr>
+        <p:txBody>
+          <a:bodyPr wrap="square">
+            <a:spAutoFit/>
+          </a:bodyPr>
+          <a:lstStyle/>
+          <a:p>
+            <a:pPr>
+              <a:defRPr b="1" sz="1400">
+                <a:solidFill>
+                  <a:srgbClr val="10B981"/>
+                </a:solidFill>
+              </a:defRPr>
+            </a:pPr>
+            <a:r>
+              <a:t>Database Features:</a:t>
+            </a:r>
+          </a:p>
+          <a:p>
+            <a:pPr>
+              <a:defRPr sz="1100">
+                <a:solidFill>
+                  <a:srgbClr val="F8FAFC"/>
+                </a:solidFill>
+              </a:defRPr>
+            </a:pPr>
+            <a:r>
+              <a:t>• Persistent Store: career_guidance.db storing all evaluated student records.</a:t>
+            </a:r>
+          </a:p>
+          <a:p>
+            <a:pPr>
+              <a:defRPr sz="1100">
+                <a:solidFill>
+                  <a:srgbClr val="F8FAFC"/>
+                </a:solidFill>
+              </a:defRPr>
+            </a:pPr>
+            <a:r>
+              <a:t>• Key Metrics: Logs candidate name, recommended role, model used, confidence %, academic average, and timestamp.</a:t>
+            </a:r>
+          </a:p>
+          <a:p>
+            <a:pPr>
+              <a:defRPr sz="1100">
+                <a:solidFill>
+                  <a:srgbClr val="F8FAFC"/>
+                </a:solidFill>
+              </a:defRPr>
+            </a:pPr>
+            <a:r>
+              <a:t>• CRUD Management: Supports individual record deletion and full history wipe.</a:t>
+            </a:r>
+          </a:p>
+        </p:txBody>
+      </p:sp>
+    </p:spTree>
+  </p:cSld>
+  <p:clrMapOvr>
+    <a:masterClrMapping/>
+  </p:clrMapOvr>
+</p:sld>
+</file>
+
+<file path=ppt/slides/slide14.xml><?xml version="1.0" encoding="utf-8"?>
+<p:sld xmlns:a="http://schemas.openxmlformats.org/drawingml/2006/main" xmlns:p="http://schemas.openxmlformats.org/presentationml/2006/main" xmlns:r="http://schemas.openxmlformats.org/officeDocument/2006/relationships">
+  <p:cSld>
+    <p:spTree>
+      <p:nvGrpSpPr>
+        <p:cNvPr id="1" name=""/>
+        <p:cNvGrpSpPr/>
+        <p:nvPr/>
+      </p:nvGrpSpPr>
+      <p:grpSpPr/>
+      <p:sp>
+        <p:nvSpPr>
+          <p:cNvPr id="2" name="Rectangle 1"/>
+          <p:cNvSpPr/>
+          <p:nvPr/>
+        </p:nvSpPr>
+        <p:spPr>
+          <a:xfrm>
+            <a:off x="0" y="0"/>
+            <a:ext cx="12191695" cy="6858000"/>
+          </a:xfrm>
+          <a:prstGeom prst="rect">
+            <a:avLst/>
+          </a:prstGeom>
+          <a:solidFill>
+            <a:srgbClr val="0F172A"/>
+          </a:solidFill>
+          <a:ln>
+            <a:noFill/>
+          </a:ln>
+        </p:spPr>
+        <p:style>
+          <a:lnRef idx="1">
+            <a:schemeClr val="accent1"/>
+          </a:lnRef>
+          <a:fillRef idx="3">
+            <a:schemeClr val="accent1"/>
+          </a:fillRef>
+          <a:effectRef idx="2">
+            <a:schemeClr val="accent1"/>
+          </a:effectRef>
+          <a:fontRef idx="minor">
+            <a:schemeClr val="lt1"/>
+          </a:fontRef>
+        </p:style>
+        <p:txBody>
+          <a:bodyPr rtlCol="0" anchor="ctr"/>
+          <a:lstStyle/>
+          <a:p>
+            <a:pPr algn="ctr"/>
+          </a:p>
+        </p:txBody>
+      </p:sp>
+      <p:sp>
+        <p:nvSpPr>
+          <p:cNvPr id="3" name="TextBox 2"/>
+          <p:cNvSpPr txBox="1"/>
+          <p:nvPr/>
+        </p:nvSpPr>
+        <p:spPr>
+          <a:xfrm>
+            <a:off x="731520" y="457200"/>
+            <a:ext cx="10728655" cy="1005840"/>
+          </a:xfrm>
+          <a:prstGeom prst="rect">
+            <a:avLst/>
+          </a:prstGeom>
+          <a:noFill/>
+        </p:spPr>
+        <p:txBody>
+          <a:bodyPr wrap="square">
+            <a:spAutoFit/>
+          </a:bodyPr>
+          <a:lstStyle/>
+          <a:p>
+            <a:pPr>
+              <a:defRPr sz="1100" b="1">
+                <a:solidFill>
+                  <a:srgbClr val="6366F1"/>
+                </a:solidFill>
+              </a:defRPr>
+            </a:pPr>
+            <a:r>
+              <a:t>STUDENT CAREER INTELLIGENCE &amp; APPLIED MACHINE LEARNING</a:t>
+            </a:r>
+          </a:p>
+          <a:p>
+            <a:pPr>
+              <a:defRPr sz="2200" b="1">
+                <a:solidFill>
+                  <a:srgbClr val="F8FAFC"/>
+                </a:solidFill>
+              </a:defRPr>
+            </a:pPr>
+            <a:r>
+              <a:t>Automated QA Testing &amp; Software Verification</a:t>
+            </a:r>
+          </a:p>
+        </p:txBody>
+      </p:sp>
+      <p:sp>
+        <p:nvSpPr>
+          <p:cNvPr id="4" name="TextBox 3"/>
+          <p:cNvSpPr txBox="1"/>
+          <p:nvPr/>
+        </p:nvSpPr>
+        <p:spPr>
+          <a:xfrm>
+            <a:off x="731520" y="1645920"/>
+            <a:ext cx="10728655" cy="4572000"/>
+          </a:xfrm>
+          <a:prstGeom prst="rect">
+            <a:avLst/>
+          </a:prstGeom>
+          <a:noFill/>
+        </p:spPr>
+        <p:txBody>
+          <a:bodyPr wrap="square">
+            <a:spAutoFit/>
+          </a:bodyPr>
+          <a:lstStyle/>
+          <a:p/>
+          <a:p>
+            <a:pPr>
+              <a:defRPr b="1" sz="1400">
+                <a:solidFill>
+                  <a:srgbClr val="6366F1"/>
+                </a:solidFill>
+              </a:defRPr>
+            </a:pPr>
+            <a:r>
+              <a:t>• 18/18 Automated Pytest Test Cases Passed (100%): </a:t>
+            </a:r>
+            <a:r>
+              <a:rPr b="0">
+                <a:solidFill>
+                  <a:srgbClr val="F8FAFC"/>
+                </a:solidFill>
+              </a:rPr>
+              <a:t>Full test suite executed in 1.04 seconds covering all models, Flask endpoints, database transactions, and latency boundaries.</a:t>
+            </a:r>
+          </a:p>
+          <a:p>
+            <a:pPr>
+              <a:defRPr b="1" sz="1400">
+                <a:solidFill>
+                  <a:srgbClr val="6366F1"/>
+                </a:solidFill>
+              </a:defRPr>
+            </a:pPr>
+            <a:r>
+              <a:t>• Model Loading &amp; Cache Integrity: </a:t>
+            </a:r>
+            <a:r>
+              <a:rPr b="0">
+                <a:solidFill>
+                  <a:srgbClr val="F8FAFC"/>
+                </a:solidFill>
+              </a:rPr>
+              <a:t>Verified in-memory loading of Decision Tree, Random Forest, and XGBoost models without deserialization warnings.</a:t>
+            </a:r>
+          </a:p>
+          <a:p>
+            <a:pPr>
+              <a:defRPr b="1" sz="1400">
+                <a:solidFill>
+                  <a:srgbClr val="6366F1"/>
+                </a:solidFill>
+              </a:defRPr>
+            </a:pPr>
+            <a:r>
+              <a:t>• Multi-Model Output Verification: </a:t>
+            </a:r>
+            <a:r>
+              <a:rPr b="0">
+                <a:solidFill>
+                  <a:srgbClr val="F8FAFC"/>
+                </a:solidFill>
+              </a:rPr>
+              <a:t>Confirmed identical schema output (suggested_role, confidence, alternatives, insights) across all three classifier architectures.</a:t>
+            </a:r>
+          </a:p>
+          <a:p>
+            <a:pPr>
+              <a:defRPr b="1" sz="1400">
+                <a:solidFill>
+                  <a:srgbClr val="6366F1"/>
+                </a:solidFill>
+              </a:defRPr>
+            </a:pPr>
+            <a:r>
+              <a:t>• SQLite CRUD &amp; Persistence Flow: </a:t>
+            </a:r>
+            <a:r>
+              <a:rPr b="0">
+                <a:solidFill>
+                  <a:srgbClr val="F8FAFC"/>
+                </a:solidFill>
+              </a:rPr>
+              <a:t>Tested assessment creation, retrieval via /api/history, and single record deletion via /api/history/&lt;id&gt;.</a:t>
+            </a:r>
+          </a:p>
+          <a:p>
+            <a:pPr>
+              <a:defRPr b="1" sz="1400">
+                <a:solidFill>
+                  <a:srgbClr val="6366F1"/>
+                </a:solidFill>
+              </a:defRPr>
+            </a:pPr>
+            <a:r>
+              <a:t>• Boundary &amp; Latency Verification: </a:t>
+            </a:r>
+            <a:r>
+              <a:rPr b="0">
+                <a:solidFill>
+                  <a:srgbClr val="F8FAFC"/>
+                </a:solidFill>
+              </a:rPr>
+              <a:t>Validated graceful handling of empty/corrupt profiles and confirmed sub-50ms CPU inference speed.</a:t>
+            </a:r>
+          </a:p>
+        </p:txBody>
+      </p:sp>
+    </p:spTree>
+  </p:cSld>
+  <p:clrMapOvr>
+    <a:masterClrMapping/>
+  </p:clrMapOvr>
+</p:sld>
+</file>
+
+<file path=ppt/slides/slide15.xml><?xml version="1.0" encoding="utf-8"?>
+<p:sld xmlns:a="http://schemas.openxmlformats.org/drawingml/2006/main" xmlns:p="http://schemas.openxmlformats.org/presentationml/2006/main" xmlns:r="http://schemas.openxmlformats.org/officeDocument/2006/relationships">
+  <p:cSld>
+    <p:spTree>
+      <p:nvGrpSpPr>
+        <p:cNvPr id="1" name=""/>
+        <p:cNvGrpSpPr/>
+        <p:nvPr/>
+      </p:nvGrpSpPr>
+      <p:grpSpPr/>
+      <p:sp>
+        <p:nvSpPr>
+          <p:cNvPr id="2" name="Rectangle 1"/>
+          <p:cNvSpPr/>
+          <p:nvPr/>
+        </p:nvSpPr>
+        <p:spPr>
+          <a:xfrm>
+            <a:off x="0" y="0"/>
+            <a:ext cx="12191695" cy="6858000"/>
+          </a:xfrm>
+          <a:prstGeom prst="rect">
+            <a:avLst/>
+          </a:prstGeom>
+          <a:solidFill>
+            <a:srgbClr val="0F172A"/>
+          </a:solidFill>
+          <a:ln>
+            <a:noFill/>
+          </a:ln>
+        </p:spPr>
+        <p:style>
+          <a:lnRef idx="1">
+            <a:schemeClr val="accent1"/>
+          </a:lnRef>
+          <a:fillRef idx="3">
+            <a:schemeClr val="accent1"/>
+          </a:fillRef>
+          <a:effectRef idx="2">
+            <a:schemeClr val="accent1"/>
+          </a:effectRef>
+          <a:fontRef idx="minor">
+            <a:schemeClr val="lt1"/>
+          </a:fontRef>
+        </p:style>
+        <p:txBody>
+          <a:bodyPr rtlCol="0" anchor="ctr"/>
+          <a:lstStyle/>
+          <a:p>
+            <a:pPr algn="ctr"/>
+          </a:p>
+        </p:txBody>
+      </p:sp>
+      <p:sp>
+        <p:nvSpPr>
+          <p:cNvPr id="3" name="TextBox 2"/>
+          <p:cNvSpPr txBox="1"/>
+          <p:nvPr/>
+        </p:nvSpPr>
+        <p:spPr>
+          <a:xfrm>
+            <a:off x="731520" y="457200"/>
+            <a:ext cx="10728655" cy="1005840"/>
+          </a:xfrm>
+          <a:prstGeom prst="rect">
+            <a:avLst/>
+          </a:prstGeom>
+          <a:noFill/>
+        </p:spPr>
+        <p:txBody>
+          <a:bodyPr wrap="square">
+            <a:spAutoFit/>
+          </a:bodyPr>
+          <a:lstStyle/>
+          <a:p>
+            <a:pPr>
+              <a:defRPr sz="1100" b="1">
+                <a:solidFill>
+                  <a:srgbClr val="6366F1"/>
+                </a:solidFill>
+              </a:defRPr>
+            </a:pPr>
+            <a:r>
+              <a:t>STUDENT CAREER INTELLIGENCE &amp; APPLIED MACHINE LEARNING</a:t>
+            </a:r>
+          </a:p>
+          <a:p>
+            <a:pPr>
+              <a:defRPr sz="2200" b="1">
+                <a:solidFill>
+                  <a:srgbClr val="F8FAFC"/>
+                </a:solidFill>
+              </a:defRPr>
+            </a:pPr>
+            <a:r>
+              <a:t>Conclusion, Educational Impact &amp; Future Scope</a:t>
+            </a:r>
+          </a:p>
+        </p:txBody>
+      </p:sp>
+      <p:sp>
+        <p:nvSpPr>
+          <p:cNvPr id="4" name="TextBox 3"/>
+          <p:cNvSpPr txBox="1"/>
+          <p:nvPr/>
+        </p:nvSpPr>
+        <p:spPr>
+          <a:xfrm>
+            <a:off x="731520" y="1645920"/>
+            <a:ext cx="10728655" cy="4572000"/>
+          </a:xfrm>
+          <a:prstGeom prst="rect">
+            <a:avLst/>
+          </a:prstGeom>
+          <a:noFill/>
+        </p:spPr>
+        <p:txBody>
+          <a:bodyPr wrap="square">
+            <a:spAutoFit/>
+          </a:bodyPr>
+          <a:lstStyle/>
+          <a:p/>
+          <a:p>
+            <a:pPr>
+              <a:defRPr b="1" sz="1400">
+                <a:solidFill>
+                  <a:srgbClr val="10B981"/>
+                </a:solidFill>
+              </a:defRPr>
+            </a:pPr>
+            <a:r>
+              <a:t>• Final-Year Project Delivery: </a:t>
+            </a:r>
+            <a:r>
+              <a:rPr b="0">
+                <a:solidFill>
+                  <a:srgbClr val="F8FAFC"/>
+                </a:solidFill>
+              </a:rPr>
+              <a:t>Delivered a complete, fully functional AI-assisted career counseling system with 3 trained ML models, modern web portal, SQLite audit trail, and 18 automated tests.</a:t>
+            </a:r>
+          </a:p>
+          <a:p>
+            <a:pPr>
+              <a:defRPr b="1" sz="1400">
+                <a:solidFill>
+                  <a:srgbClr val="10B981"/>
+                </a:solidFill>
+              </a:defRPr>
+            </a:pPr>
+            <a:r>
+              <a:t>• Academic &amp; Practical Value: </a:t>
+            </a:r>
+            <a:r>
+              <a:rPr b="0">
+                <a:solidFill>
+                  <a:srgbClr val="F8FAFC"/>
+                </a:solidFill>
+              </a:rPr>
+              <a:t>Provides universities with an automated, scalable career guidance solution that empowers students with objective skills gap analyses.</a:t>
+            </a:r>
+          </a:p>
+          <a:p>
+            <a:pPr>
+              <a:defRPr b="1" sz="1400">
+                <a:solidFill>
+                  <a:srgbClr val="10B981"/>
+                </a:solidFill>
+              </a:defRPr>
+            </a:pPr>
+            <a:r>
+              <a:t>• Future Roadmap - LLM Resume Ingestion: </a:t>
+            </a:r>
+            <a:r>
+              <a:rPr b="0">
+                <a:solidFill>
+                  <a:srgbClr val="F8FAFC"/>
+                </a:solidFill>
+              </a:rPr>
+              <a:t>Integrate multimodal Large Language Models (Gemini/Llama) to automatically extract skills, projects, and coursework directly from student PDF resumes.</a:t>
+            </a:r>
+          </a:p>
+          <a:p>
+            <a:pPr>
+              <a:defRPr b="1" sz="1400">
+                <a:solidFill>
+                  <a:srgbClr val="10B981"/>
+                </a:solidFill>
+              </a:defRPr>
+            </a:pPr>
+            <a:r>
+              <a:t>• Real-Time Job Market Scraping: </a:t>
+            </a:r>
+            <a:r>
+              <a:rPr b="0">
+                <a:solidFill>
+                  <a:srgbClr val="F8FAFC"/>
+                </a:solidFill>
+              </a:rPr>
+              <a:t>Connect live scrapers to LinkedIn and Indeed APIs to dynamically index salary trends and hiring demand across global metropolitan hubs.</a:t>
             </a:r>
           </a:p>
         </p:txBody>
@@ -3230,7 +4488,7 @@
         <p:spPr>
           <a:xfrm>
             <a:off x="0" y="0"/>
-            <a:ext cx="12191695" cy="1097280"/>
+            <a:ext cx="12191695" cy="6858000"/>
           </a:xfrm>
           <a:prstGeom prst="rect">
             <a:avLst/>
@@ -3272,8 +4530,8 @@
         </p:nvSpPr>
         <p:spPr>
           <a:xfrm>
-            <a:off x="731520" y="137160"/>
-            <a:ext cx="10698480" cy="822960"/>
+            <a:off x="731520" y="457200"/>
+            <a:ext cx="10728655" cy="1005840"/>
           </a:xfrm>
           <a:prstGeom prst="rect">
             <a:avLst/>
@@ -3287,26 +4545,26 @@
           <a:lstStyle/>
           <a:p>
             <a:pPr>
-              <a:defRPr sz="2400" b="1">
-                <a:solidFill>
-                  <a:srgbClr val="FFFFFF"/>
-                </a:solidFill>
-              </a:defRPr>
-            </a:pPr>
-            <a:r>
-              <a:t>1. Background &amp; Industrial Motivation</a:t>
-            </a:r>
-          </a:p>
-          <a:p>
-            <a:pPr>
-              <a:defRPr sz="1100">
-                <a:solidFill>
-                  <a:srgbClr val="94A3B8"/>
-                </a:solidFill>
-              </a:defRPr>
-            </a:pPr>
-            <a:r>
-              <a:t>Academic &amp; Industrial AI Project Series  |  Project 05 of 55</a:t>
+              <a:defRPr sz="1100" b="1">
+                <a:solidFill>
+                  <a:srgbClr val="6366F1"/>
+                </a:solidFill>
+              </a:defRPr>
+            </a:pPr>
+            <a:r>
+              <a:t>STUDENT CAREER INTELLIGENCE &amp; APPLIED MACHINE LEARNING</a:t>
+            </a:r>
+          </a:p>
+          <a:p>
+            <a:pPr>
+              <a:defRPr sz="2200" b="1">
+                <a:solidFill>
+                  <a:srgbClr val="F8FAFC"/>
+                </a:solidFill>
+              </a:defRPr>
+            </a:pPr>
+            <a:r>
+              <a:t>Executive Summary &amp; Project Abstract</a:t>
             </a:r>
           </a:p>
         </p:txBody>
@@ -3319,8 +4577,8 @@
         </p:nvSpPr>
         <p:spPr>
           <a:xfrm>
-            <a:off x="731520" y="1371600"/>
-            <a:ext cx="10698480" cy="5029200"/>
+            <a:off x="731520" y="1645920"/>
+            <a:ext cx="10728655" cy="4572000"/>
           </a:xfrm>
           <a:prstGeom prst="rect">
             <a:avLst/>
@@ -3332,87 +4590,85 @@
             <a:spAutoFit/>
           </a:bodyPr>
           <a:lstStyle/>
-          <a:p>
-            <a:pPr>
-              <a:defRPr sz="1800" b="1">
-                <a:solidFill>
-                  <a:srgbClr val="1E3A8A"/>
-                </a:solidFill>
-              </a:defRPr>
-            </a:pPr>
-            <a:r>
-              <a:t>Executive Problem Background:</a:t>
-            </a:r>
-          </a:p>
-          <a:p>
-            <a:pPr>
-              <a:spcBef>
-                <a:spcPts val="1000"/>
-              </a:spcBef>
-              <a:defRPr sz="1400">
-                <a:solidFill>
-                  <a:srgbClr val="334155"/>
-                </a:solidFill>
-              </a:defRPr>
-            </a:pPr>
-            <a:r>
-              <a:t>In response to the complex challenges students encounter in navigating their career paths, our innovative approach integrates AI assistance into career guidance. By utilizing Support Vector Machine (SVM) algorithms, we enhance interaction and efficiency within the guidance process. Our model ensures high accuracy and predictive capabilities, enabling precise recommendations for career trajectories. The efficiency techniques embedded in our model contribute to its accuracy, ensuring students rece...</a:t>
-            </a:r>
-          </a:p>
-          <a:p>
-            <a:pPr>
-              <a:spcBef>
-                <a:spcPts val="1400"/>
-              </a:spcBef>
-              <a:defRPr sz="1600" b="1"/>
-            </a:pPr>
-            <a:r>
-              <a:t>Core Industry Drivers:</a:t>
-            </a:r>
-          </a:p>
-          <a:p>
-            <a:pPr>
-              <a:spcBef>
-                <a:spcPts val="400"/>
-              </a:spcBef>
-              <a:defRPr sz="1300">
-                <a:solidFill>
-                  <a:srgbClr val="475569"/>
-                </a:solidFill>
-              </a:defRPr>
-            </a:pPr>
-            <a:r>
-              <a:t>• Manual legacy inspection/decision methods incur high operational costs, delay, and human error.</a:t>
-            </a:r>
-          </a:p>
-          <a:p>
-            <a:pPr>
-              <a:spcBef>
-                <a:spcPts val="400"/>
-              </a:spcBef>
-              <a:defRPr sz="1300">
-                <a:solidFill>
-                  <a:srgbClr val="475569"/>
-                </a:solidFill>
-              </a:defRPr>
-            </a:pPr>
-            <a:r>
-              <a:t>• Scalable automated solutions require low-latency edge and cloud neural network inference.</a:t>
-            </a:r>
-          </a:p>
-          <a:p>
-            <a:pPr>
-              <a:spcBef>
-                <a:spcPts val="400"/>
-              </a:spcBef>
-              <a:defRPr sz="1300">
-                <a:solidFill>
-                  <a:srgbClr val="475569"/>
-                </a:solidFill>
-              </a:defRPr>
-            </a:pPr>
-            <a:r>
-              <a:t>• Explainable prediction confidence metrics are essential for operational trust and regulatory compliance.</a:t>
+          <a:p/>
+          <a:p>
+            <a:pPr>
+              <a:defRPr b="1" sz="1400">
+                <a:solidFill>
+                  <a:srgbClr val="6366F1"/>
+                </a:solidFill>
+              </a:defRPr>
+            </a:pPr>
+            <a:r>
+              <a:t>• The Career Counseling Dilemma: </a:t>
+            </a:r>
+            <a:r>
+              <a:rPr b="0">
+                <a:solidFill>
+                  <a:srgbClr val="F8FAFC"/>
+                </a:solidFill>
+              </a:rPr>
+              <a:t>Undergraduate engineering students face severe ambiguity when navigating high-tech career options, often suffering from cognitive bias, lack of personalized mentoring, and misaligned skill development.</a:t>
+            </a:r>
+          </a:p>
+          <a:p>
+            <a:pPr>
+              <a:defRPr b="1" sz="1400">
+                <a:solidFill>
+                  <a:srgbClr val="6366F1"/>
+                </a:solidFill>
+              </a:defRPr>
+            </a:pPr>
+            <a:r>
+              <a:t>• Multi-Dimensional Machine Learning: </a:t>
+            </a:r>
+            <a:r>
+              <a:rPr b="0">
+                <a:solidFill>
+                  <a:srgbClr val="F8FAFC"/>
+                </a:solidFill>
+              </a:rPr>
+              <a:t>We develop Career Guidance AI: an intelligent counseling platform trained on 20,000 multi-dimensional student profiles across 38 academic, coding, and behavioral features spanning 34 technology job roles.</a:t>
+            </a:r>
+          </a:p>
+          <a:p>
+            <a:pPr>
+              <a:defRPr b="1" sz="1400">
+                <a:solidFill>
+                  <a:srgbClr val="6366F1"/>
+                </a:solidFill>
+              </a:defRPr>
+            </a:pPr>
+            <a:r>
+              <a:t>• Ensemble Model Comparison: </a:t>
+            </a:r>
+            <a:r>
+              <a:rPr b="0">
+                <a:solidFill>
+                  <a:srgbClr val="F8FAFC"/>
+                </a:solidFill>
+              </a:rPr>
+              <a:t>Benchmarks three supervised learning paradigms: Extreme Gradient Boosting (XGBoost), Random Forest, and Decision Trees, delivering sub-10ms real-time inference latency.</a:t>
+            </a:r>
+          </a:p>
+          <a:p>
+            <a:pPr>
+              <a:defRPr b="1" sz="1400">
+                <a:solidFill>
+                  <a:srgbClr val="6366F1"/>
+                </a:solidFill>
+              </a:defRPr>
+            </a:pPr>
+            <a:r>
+              <a:t>• Comprehensive Career Intelligence: </a:t>
+            </a:r>
+            <a:r>
+              <a:rPr b="0">
+                <a:solidFill>
+                  <a:srgbClr val="F8FAFC"/>
+                </a:solidFill>
+              </a:rPr>
+              <a:t>Goes beyond simple role prediction by generating top alternative career matches, salary benchmarks (USD and INR LPA), required skill matrices, and industry-recognized professional certifications.</a:t>
             </a:r>
           </a:p>
         </p:txBody>
@@ -3444,7 +4700,7 @@
         <p:spPr>
           <a:xfrm>
             <a:off x="0" y="0"/>
-            <a:ext cx="12191695" cy="1097280"/>
+            <a:ext cx="12191695" cy="6858000"/>
           </a:xfrm>
           <a:prstGeom prst="rect">
             <a:avLst/>
@@ -3486,8 +4742,8 @@
         </p:nvSpPr>
         <p:spPr>
           <a:xfrm>
-            <a:off x="731520" y="137160"/>
-            <a:ext cx="10698480" cy="822960"/>
+            <a:off x="731520" y="457200"/>
+            <a:ext cx="10728655" cy="1005840"/>
           </a:xfrm>
           <a:prstGeom prst="rect">
             <a:avLst/>
@@ -3501,26 +4757,26 @@
           <a:lstStyle/>
           <a:p>
             <a:pPr>
-              <a:defRPr sz="2400" b="1">
-                <a:solidFill>
-                  <a:srgbClr val="FFFFFF"/>
-                </a:solidFill>
-              </a:defRPr>
-            </a:pPr>
-            <a:r>
-              <a:t>2. Problem Statement &amp; Key Objectives</a:t>
-            </a:r>
-          </a:p>
-          <a:p>
-            <a:pPr>
-              <a:defRPr sz="1100">
-                <a:solidFill>
-                  <a:srgbClr val="94A3B8"/>
-                </a:solidFill>
-              </a:defRPr>
-            </a:pPr>
-            <a:r>
-              <a:t>Academic &amp; Industrial AI Project Series  |  Project 05 of 55</a:t>
+              <a:defRPr sz="1100" b="1">
+                <a:solidFill>
+                  <a:srgbClr val="6366F1"/>
+                </a:solidFill>
+              </a:defRPr>
+            </a:pPr>
+            <a:r>
+              <a:t>STUDENT CAREER INTELLIGENCE &amp; APPLIED MACHINE LEARNING</a:t>
+            </a:r>
+          </a:p>
+          <a:p>
+            <a:pPr>
+              <a:defRPr sz="2200" b="1">
+                <a:solidFill>
+                  <a:srgbClr val="F8FAFC"/>
+                </a:solidFill>
+              </a:defRPr>
+            </a:pPr>
+            <a:r>
+              <a:t>Academic &amp; Market Counseling Challenges</a:t>
             </a:r>
           </a:p>
         </p:txBody>
@@ -3533,8 +4789,8 @@
         </p:nvSpPr>
         <p:spPr>
           <a:xfrm>
-            <a:off x="731520" y="1371600"/>
-            <a:ext cx="10698480" cy="5029200"/>
+            <a:off x="731520" y="1645920"/>
+            <a:ext cx="10728655" cy="4572000"/>
           </a:xfrm>
           <a:prstGeom prst="rect">
             <a:avLst/>
@@ -3546,124 +4802,85 @@
             <a:spAutoFit/>
           </a:bodyPr>
           <a:lstStyle/>
-          <a:p>
-            <a:pPr>
-              <a:spcBef>
-                <a:spcPts val="800"/>
-              </a:spcBef>
-              <a:defRPr sz="1600" b="1">
-                <a:solidFill>
-                  <a:srgbClr val="10B981"/>
-                </a:solidFill>
-              </a:defRPr>
-            </a:pPr>
-            <a:r>
-              <a:t>✓ Predictive Accuracy &amp; Generalization</a:t>
-            </a:r>
-          </a:p>
-          <a:p>
-            <a:pPr>
-              <a:spcBef>
-                <a:spcPts val="200"/>
-              </a:spcBef>
-              <a:defRPr sz="1300">
-                <a:solidFill>
-                  <a:srgbClr val="475569"/>
-                </a:solidFill>
-              </a:defRPr>
-            </a:pPr>
-            <a:r>
-              <a:t>Achieve high validation precision across diverse real-world operating distributions.</a:t>
-            </a:r>
-          </a:p>
-          <a:p>
-            <a:pPr>
-              <a:spcBef>
-                <a:spcPts val="800"/>
-              </a:spcBef>
-              <a:defRPr sz="1600" b="1">
-                <a:solidFill>
-                  <a:srgbClr val="10B981"/>
-                </a:solidFill>
-              </a:defRPr>
-            </a:pPr>
-            <a:r>
-              <a:t>✓ Real-Time Low Latency Inference</a:t>
-            </a:r>
-          </a:p>
-          <a:p>
-            <a:pPr>
-              <a:spcBef>
-                <a:spcPts val="200"/>
-              </a:spcBef>
-              <a:defRPr sz="1300">
-                <a:solidFill>
-                  <a:srgbClr val="475569"/>
-                </a:solidFill>
-              </a:defRPr>
-            </a:pPr>
-            <a:r>
-              <a:t>Deliver end-to-end processing response times under 35 milliseconds per query.</a:t>
-            </a:r>
-          </a:p>
-          <a:p>
-            <a:pPr>
-              <a:spcBef>
-                <a:spcPts val="800"/>
-              </a:spcBef>
-              <a:defRPr sz="1600" b="1">
-                <a:solidFill>
-                  <a:srgbClr val="10B981"/>
-                </a:solidFill>
-              </a:defRPr>
-            </a:pPr>
-            <a:r>
-              <a:t>✓ Robust Anomaly &amp; Boundary Handling</a:t>
-            </a:r>
-          </a:p>
-          <a:p>
-            <a:pPr>
-              <a:spcBef>
-                <a:spcPts val="200"/>
-              </a:spcBef>
-              <a:defRPr sz="1300">
-                <a:solidFill>
-                  <a:srgbClr val="475569"/>
-                </a:solidFill>
-              </a:defRPr>
-            </a:pPr>
-            <a:r>
-              <a:t>Detect out-of-distribution instances and reject anomalous inputs with deterministic alerts.</a:t>
-            </a:r>
-          </a:p>
-          <a:p>
-            <a:pPr>
-              <a:spcBef>
-                <a:spcPts val="800"/>
-              </a:spcBef>
-              <a:defRPr sz="1600" b="1">
-                <a:solidFill>
-                  <a:srgbClr val="10B981"/>
-                </a:solidFill>
-              </a:defRPr>
-            </a:pPr>
-            <a:r>
-              <a:t>✓ Production-Ready Full Stack</a:t>
-            </a:r>
-          </a:p>
-          <a:p>
-            <a:pPr>
-              <a:spcBef>
-                <a:spcPts val="200"/>
-              </a:spcBef>
-              <a:defRPr sz="1300">
-                <a:solidFill>
-                  <a:srgbClr val="475569"/>
-                </a:solidFill>
-              </a:defRPr>
-            </a:pPr>
-            <a:r>
-              <a:t>Provide modular REST APIs, audit logging, and responsive user interfaces.</a:t>
+          <a:p/>
+          <a:p>
+            <a:pPr>
+              <a:defRPr b="1" sz="1400">
+                <a:solidFill>
+                  <a:srgbClr val="F59E0B"/>
+                </a:solidFill>
+              </a:defRPr>
+            </a:pPr>
+            <a:r>
+              <a:t>• Human Counseling Bandwidth Limits: </a:t>
+            </a:r>
+            <a:r>
+              <a:rPr b="0">
+                <a:solidFill>
+                  <a:srgbClr val="F8FAFC"/>
+                </a:solidFill>
+              </a:rPr>
+              <a:t>University career advisory centers operate at student-to-counselor ratios exceeding 600:1, making individualized career pathing impossible.</a:t>
+            </a:r>
+          </a:p>
+          <a:p>
+            <a:pPr>
+              <a:defRPr b="1" sz="1400">
+                <a:solidFill>
+                  <a:srgbClr val="F59E0B"/>
+                </a:solidFill>
+              </a:defRPr>
+            </a:pPr>
+            <a:r>
+              <a:t>• Cognitive &amp; Academic Mismatch: </a:t>
+            </a:r>
+            <a:r>
+              <a:rPr b="0">
+                <a:solidFill>
+                  <a:srgbClr val="F8FAFC"/>
+                </a:solidFill>
+              </a:rPr>
+              <a:t>Students frequently pursue trending job titles (e.g., AI/Data Science) without evaluating foundational strengths in Operating Systems, Computer Architecture, or discrete mathematics.</a:t>
+            </a:r>
+          </a:p>
+          <a:p>
+            <a:pPr>
+              <a:defRPr b="1" sz="1400">
+                <a:solidFill>
+                  <a:srgbClr val="F59E0B"/>
+                </a:solidFill>
+              </a:defRPr>
+            </a:pPr>
+            <a:r>
+              <a:t>• Multi-Class Role Complexity: </a:t>
+            </a:r>
+            <a:r>
+              <a:rPr b="0">
+                <a:solidFill>
+                  <a:srgbClr val="F8FAFC"/>
+                </a:solidFill>
+              </a:rPr>
+              <a:t>The modern technology ecosystem encompasses over 30 distinct specializations (DevOps, Cloud, Information Security, Database Administration, Systems Engineering) that manual tests oversimplify.</a:t>
+            </a:r>
+          </a:p>
+          <a:p>
+            <a:pPr>
+              <a:defRPr b="1" sz="1400">
+                <a:solidFill>
+                  <a:srgbClr val="F59E0B"/>
+                </a:solidFill>
+              </a:defRPr>
+            </a:pPr>
+            <a:r>
+              <a:t>• Need for Actionable Roadmaps: </a:t>
+            </a:r>
+            <a:r>
+              <a:rPr b="0">
+                <a:solidFill>
+                  <a:srgbClr val="F8FAFC"/>
+                </a:solidFill>
+              </a:rPr>
+              <a:t>Standard career aptitude tests merely report scores without providing immediate upskilling roadmaps, certifications, and compensation realities.</a:t>
             </a:r>
           </a:p>
         </p:txBody>
@@ -3695,7 +4912,7 @@
         <p:spPr>
           <a:xfrm>
             <a:off x="0" y="0"/>
-            <a:ext cx="12191695" cy="1097280"/>
+            <a:ext cx="12191695" cy="6858000"/>
           </a:xfrm>
           <a:prstGeom prst="rect">
             <a:avLst/>
@@ -3737,8 +4954,8 @@
         </p:nvSpPr>
         <p:spPr>
           <a:xfrm>
-            <a:off x="731520" y="137160"/>
-            <a:ext cx="10698480" cy="822960"/>
+            <a:off x="731520" y="457200"/>
+            <a:ext cx="10728655" cy="1005840"/>
           </a:xfrm>
           <a:prstGeom prst="rect">
             <a:avLst/>
@@ -3752,26 +4969,26 @@
           <a:lstStyle/>
           <a:p>
             <a:pPr>
-              <a:defRPr sz="2400" b="1">
-                <a:solidFill>
-                  <a:srgbClr val="FFFFFF"/>
-                </a:solidFill>
-              </a:defRPr>
-            </a:pPr>
-            <a:r>
-              <a:t>3. System Architecture &amp; Workflow Pipeline</a:t>
-            </a:r>
-          </a:p>
-          <a:p>
-            <a:pPr>
-              <a:defRPr sz="1100">
-                <a:solidFill>
-                  <a:srgbClr val="94A3B8"/>
-                </a:solidFill>
-              </a:defRPr>
-            </a:pPr>
-            <a:r>
-              <a:t>Academic &amp; Industrial AI Project Series  |  Project 05 of 55</a:t>
+              <a:defRPr sz="1100" b="1">
+                <a:solidFill>
+                  <a:srgbClr val="6366F1"/>
+                </a:solidFill>
+              </a:defRPr>
+            </a:pPr>
+            <a:r>
+              <a:t>STUDENT CAREER INTELLIGENCE &amp; APPLIED MACHINE LEARNING</a:t>
+            </a:r>
+          </a:p>
+          <a:p>
+            <a:pPr>
+              <a:defRPr sz="2200" b="1">
+                <a:solidFill>
+                  <a:srgbClr val="F8FAFC"/>
+                </a:solidFill>
+              </a:defRPr>
+            </a:pPr>
+            <a:r>
+              <a:t>System Architecture &amp; Engineering Pipeline</a:t>
             </a:r>
           </a:p>
         </p:txBody>
@@ -3784,8 +5001,8 @@
         </p:nvSpPr>
         <p:spPr>
           <a:xfrm>
-            <a:off x="731520" y="1371600"/>
-            <a:ext cx="10698480" cy="5029200"/>
+            <a:off x="731520" y="1645920"/>
+            <a:ext cx="10728655" cy="4572000"/>
           </a:xfrm>
           <a:prstGeom prst="rect">
             <a:avLst/>
@@ -3797,139 +5014,105 @@
             <a:spAutoFit/>
           </a:bodyPr>
           <a:lstStyle/>
-          <a:p>
-            <a:pPr>
-              <a:spcBef>
-                <a:spcPts val="800"/>
-              </a:spcBef>
-              <a:defRPr sz="1500" b="1">
-                <a:solidFill>
-                  <a:srgbClr val="2563EB"/>
-                </a:solidFill>
-              </a:defRPr>
-            </a:pPr>
-            <a:r>
-              <a:t>[1] Ingestion Layer</a:t>
-            </a:r>
-          </a:p>
-          <a:p>
-            <a:pPr>
-              <a:defRPr sz="1300">
-                <a:solidFill>
-                  <a:srgbClr val="475569"/>
-                </a:solidFill>
-              </a:defRPr>
-            </a:pPr>
-            <a:r>
-              <a:t>Raw telemetry, video feeds, or structured tabular features ingested via secure endpoints.</a:t>
-            </a:r>
-          </a:p>
-          <a:p>
-            <a:pPr>
-              <a:spcBef>
-                <a:spcPts val="800"/>
-              </a:spcBef>
-              <a:defRPr sz="1500" b="1">
-                <a:solidFill>
-                  <a:srgbClr val="2563EB"/>
-                </a:solidFill>
-              </a:defRPr>
-            </a:pPr>
-            <a:r>
-              <a:t>[2] Preprocessing &amp; Normalization</a:t>
-            </a:r>
-          </a:p>
-          <a:p>
-            <a:pPr>
-              <a:defRPr sz="1300">
-                <a:solidFill>
-                  <a:srgbClr val="475569"/>
-                </a:solidFill>
-              </a:defRPr>
-            </a:pPr>
-            <a:r>
-              <a:t>Feature scaling, missing value imputation, winsorization, and tensor reshaping.</a:t>
-            </a:r>
-          </a:p>
-          <a:p>
-            <a:pPr>
-              <a:spcBef>
-                <a:spcPts val="800"/>
-              </a:spcBef>
-              <a:defRPr sz="1500" b="1">
-                <a:solidFill>
-                  <a:srgbClr val="2563EB"/>
-                </a:solidFill>
-              </a:defRPr>
-            </a:pPr>
-            <a:r>
-              <a:t>[3] Deep Neural Inference Engine</a:t>
-            </a:r>
-          </a:p>
-          <a:p>
-            <a:pPr>
-              <a:defRPr sz="1300">
-                <a:solidFill>
-                  <a:srgbClr val="475569"/>
-                </a:solidFill>
-              </a:defRPr>
-            </a:pPr>
-            <a:r>
-              <a:t>Optimized model evaluating representations with GPU/MPS/CPU acceleration.</a:t>
-            </a:r>
-          </a:p>
-          <a:p>
-            <a:pPr>
-              <a:spcBef>
-                <a:spcPts val="800"/>
-              </a:spcBef>
-              <a:defRPr sz="1500" b="1">
-                <a:solidFill>
-                  <a:srgbClr val="2563EB"/>
-                </a:solidFill>
-              </a:defRPr>
-            </a:pPr>
-            <a:r>
-              <a:t>[4] Post-Processing &amp; Decision Support</a:t>
-            </a:r>
-          </a:p>
-          <a:p>
-            <a:pPr>
-              <a:defRPr sz="1300">
-                <a:solidFill>
-                  <a:srgbClr val="475569"/>
-                </a:solidFill>
-              </a:defRPr>
-            </a:pPr>
-            <a:r>
-              <a:t>Threshold calibration, confidence scoring, classification/regression output formatting.</a:t>
-            </a:r>
-          </a:p>
-          <a:p>
-            <a:pPr>
-              <a:spcBef>
-                <a:spcPts val="800"/>
-              </a:spcBef>
-              <a:defRPr sz="1500" b="1">
-                <a:solidFill>
-                  <a:srgbClr val="2563EB"/>
-                </a:solidFill>
-              </a:defRPr>
-            </a:pPr>
-            <a:r>
-              <a:t>[5] Visualization &amp; Persistence</a:t>
-            </a:r>
-          </a:p>
-          <a:p>
-            <a:pPr>
-              <a:defRPr sz="1300">
-                <a:solidFill>
-                  <a:srgbClr val="475569"/>
-                </a:solidFill>
-              </a:defRPr>
-            </a:pPr>
-            <a:r>
-              <a:t>Interactive UI dashboard rendering metrics and SQLite/PostgreSQL audit logging.</a:t>
+          <a:p/>
+          <a:p>
+            <a:pPr>
+              <a:defRPr b="1" sz="1400">
+                <a:solidFill>
+                  <a:srgbClr val="10B981"/>
+                </a:solidFill>
+              </a:defRPr>
+            </a:pPr>
+            <a:r>
+              <a:t>• Client Tier: </a:t>
+            </a:r>
+            <a:r>
+              <a:rPr b="0">
+                <a:solidFill>
+                  <a:srgbClr val="F8FAFC"/>
+                </a:solidFill>
+              </a:rPr>
+              <a:t>Responsive dark-mode single-page application built with Tailwind CSS, FontAwesome icons, interactive sliders, and 1-click candidate presets.</a:t>
+            </a:r>
+          </a:p>
+          <a:p>
+            <a:pPr>
+              <a:defRPr b="1" sz="1400">
+                <a:solidFill>
+                  <a:srgbClr val="10B981"/>
+                </a:solidFill>
+              </a:defRPr>
+            </a:pPr>
+            <a:r>
+              <a:t>• Application Tier (Port 5005): </a:t>
+            </a:r>
+            <a:r>
+              <a:rPr b="0">
+                <a:solidFill>
+                  <a:srgbClr val="F8FAFC"/>
+                </a:solidFill>
+              </a:rPr>
+              <a:t>Flask microservice providing REST endpoints: /api/predict, /api/presets, /api/metrics, /api/health, /api/history with full CORS support.</a:t>
+            </a:r>
+          </a:p>
+          <a:p>
+            <a:pPr>
+              <a:defRPr b="1" sz="1400">
+                <a:solidFill>
+                  <a:srgbClr val="10B981"/>
+                </a:solidFill>
+              </a:defRPr>
+            </a:pPr>
+            <a:r>
+              <a:t>• ML Inference Engine: </a:t>
+            </a:r>
+            <a:r>
+              <a:rPr b="0">
+                <a:solidFill>
+                  <a:srgbClr val="F8FAFC"/>
+                </a:solidFill>
+              </a:rPr>
+              <a:t>CareerGuidanceEngine managing multi-class XGBoost, Random Forest, and Decision Tree estimators with in-memory model serialization via joblib.</a:t>
+            </a:r>
+          </a:p>
+          <a:p>
+            <a:pPr>
+              <a:defRPr b="1" sz="1400">
+                <a:solidFill>
+                  <a:srgbClr val="10B981"/>
+                </a:solidFill>
+              </a:defRPr>
+            </a:pPr>
+            <a:r>
+              <a:t>• Domain Knowledge Base: </a:t>
+            </a:r>
+            <a:r>
+              <a:rPr b="0">
+                <a:solidFill>
+                  <a:srgbClr val="F8FAFC"/>
+                </a:solidFill>
+              </a:rPr>
+              <a:t>Curated dictionary of 34 technology job roles detailing job descriptions, target skills, recommended professional credentials, and salary ranges.</a:t>
+            </a:r>
+          </a:p>
+          <a:p>
+            <a:pPr>
+              <a:defRPr b="1" sz="1400">
+                <a:solidFill>
+                  <a:srgbClr val="10B981"/>
+                </a:solidFill>
+              </a:defRPr>
+            </a:pPr>
+            <a:r>
+              <a:t>• Persistence Tier: </a:t>
+            </a:r>
+            <a:r>
+              <a:rPr b="0">
+                <a:solidFill>
+                  <a:srgbClr val="F8FAFC"/>
+                </a:solidFill>
+              </a:rPr>
+              <a:t>ACID-compliant SQLite database (career_guidance.db) recording assessment timestamps, candidate names, academic averages, and model outputs.</a:t>
             </a:r>
           </a:p>
         </p:txBody>
@@ -3961,7 +5144,7 @@
         <p:spPr>
           <a:xfrm>
             <a:off x="0" y="0"/>
-            <a:ext cx="12191695" cy="1097280"/>
+            <a:ext cx="12191695" cy="6858000"/>
           </a:xfrm>
           <a:prstGeom prst="rect">
             <a:avLst/>
@@ -4003,8 +5186,8 @@
         </p:nvSpPr>
         <p:spPr>
           <a:xfrm>
-            <a:off x="731520" y="137160"/>
-            <a:ext cx="10698480" cy="822960"/>
+            <a:off x="731520" y="457200"/>
+            <a:ext cx="10728655" cy="1005840"/>
           </a:xfrm>
           <a:prstGeom prst="rect">
             <a:avLst/>
@@ -4018,26 +5201,26 @@
           <a:lstStyle/>
           <a:p>
             <a:pPr>
-              <a:defRPr sz="2400" b="1">
-                <a:solidFill>
-                  <a:srgbClr val="FFFFFF"/>
-                </a:solidFill>
-              </a:defRPr>
-            </a:pPr>
-            <a:r>
-              <a:t>4. Deep Learning &amp; ML Methodology</a:t>
-            </a:r>
-          </a:p>
-          <a:p>
-            <a:pPr>
-              <a:defRPr sz="1100">
-                <a:solidFill>
-                  <a:srgbClr val="94A3B8"/>
-                </a:solidFill>
-              </a:defRPr>
-            </a:pPr>
-            <a:r>
-              <a:t>Academic &amp; Industrial AI Project Series  |  Project 05 of 55</a:t>
+              <a:defRPr sz="1100" b="1">
+                <a:solidFill>
+                  <a:srgbClr val="6366F1"/>
+                </a:solidFill>
+              </a:defRPr>
+            </a:pPr>
+            <a:r>
+              <a:t>STUDENT CAREER INTELLIGENCE &amp; APPLIED MACHINE LEARNING</a:t>
+            </a:r>
+          </a:p>
+          <a:p>
+            <a:pPr>
+              <a:defRPr sz="2200" b="1">
+                <a:solidFill>
+                  <a:srgbClr val="F8FAFC"/>
+                </a:solidFill>
+              </a:defRPr>
+            </a:pPr>
+            <a:r>
+              <a:t>Student Profile Dataset &amp; Exploratory Analysis</a:t>
             </a:r>
           </a:p>
         </p:txBody>
@@ -4050,8 +5233,8 @@
         </p:nvSpPr>
         <p:spPr>
           <a:xfrm>
-            <a:off x="731520" y="1371600"/>
-            <a:ext cx="10698480" cy="5029200"/>
+            <a:off x="731520" y="1645920"/>
+            <a:ext cx="10728655" cy="4572000"/>
           </a:xfrm>
           <a:prstGeom prst="rect">
             <a:avLst/>
@@ -4063,112 +5246,85 @@
             <a:spAutoFit/>
           </a:bodyPr>
           <a:lstStyle/>
-          <a:p>
-            <a:pPr>
-              <a:spcBef>
-                <a:spcPts val="800"/>
-              </a:spcBef>
-              <a:defRPr sz="1500" b="1">
-                <a:solidFill>
-                  <a:srgbClr val="0F172A"/>
-                </a:solidFill>
-              </a:defRPr>
-            </a:pPr>
-            <a:r>
-              <a:t>• Feature Engineering &amp; Dimensionality Alignment</a:t>
-            </a:r>
-          </a:p>
-          <a:p>
-            <a:pPr>
-              <a:defRPr sz="1300">
-                <a:solidFill>
-                  <a:srgbClr val="475569"/>
-                </a:solidFill>
-              </a:defRPr>
-            </a:pPr>
-            <a:r>
-              <a:t>Domain-specific feature extraction, temporal windowing, and embedding vectors.</a:t>
-            </a:r>
-          </a:p>
-          <a:p>
-            <a:pPr>
-              <a:spcBef>
-                <a:spcPts val="800"/>
-              </a:spcBef>
-              <a:defRPr sz="1500" b="1">
-                <a:solidFill>
-                  <a:srgbClr val="0F172A"/>
-                </a:solidFill>
-              </a:defRPr>
-            </a:pPr>
-            <a:r>
-              <a:t>• Model Family &amp; Optimization</a:t>
-            </a:r>
-          </a:p>
-          <a:p>
-            <a:pPr>
-              <a:defRPr sz="1300">
-                <a:solidFill>
-                  <a:srgbClr val="475569"/>
-                </a:solidFill>
-              </a:defRPr>
-            </a:pPr>
-            <a:r>
-              <a:t>Ensemble gradient boosting or deep neural networks trained with AdamW and adaptive LR scheduling.</a:t>
-            </a:r>
-          </a:p>
-          <a:p>
-            <a:pPr>
-              <a:spcBef>
-                <a:spcPts val="800"/>
-              </a:spcBef>
-              <a:defRPr sz="1500" b="1">
-                <a:solidFill>
-                  <a:srgbClr val="0F172A"/>
-                </a:solidFill>
-              </a:defRPr>
-            </a:pPr>
-            <a:r>
-              <a:t>• Overfitting Mitigation</a:t>
-            </a:r>
-          </a:p>
-          <a:p>
-            <a:pPr>
-              <a:defRPr sz="1300">
-                <a:solidFill>
-                  <a:srgbClr val="475569"/>
-                </a:solidFill>
-              </a:defRPr>
-            </a:pPr>
-            <a:r>
-              <a:t>Stratified k-fold cross-validation, dropout layers, early stopping, and data augmentation.</a:t>
-            </a:r>
-          </a:p>
-          <a:p>
-            <a:pPr>
-              <a:spcBef>
-                <a:spcPts val="800"/>
-              </a:spcBef>
-              <a:defRPr sz="1500" b="1">
-                <a:solidFill>
-                  <a:srgbClr val="0F172A"/>
-                </a:solidFill>
-              </a:defRPr>
-            </a:pPr>
-            <a:r>
-              <a:t>• Explainability &amp; Auditability</a:t>
-            </a:r>
-          </a:p>
-          <a:p>
-            <a:pPr>
-              <a:defRPr sz="1300">
-                <a:solidFill>
-                  <a:srgbClr val="475569"/>
-                </a:solidFill>
-              </a:defRPr>
-            </a:pPr>
-            <a:r>
-              <a:t>Confidence scores and feature importance attributions for high-stakes decisions.</a:t>
+          <a:p/>
+          <a:p>
+            <a:pPr>
+              <a:defRPr b="1" sz="1400">
+                <a:solidFill>
+                  <a:srgbClr val="6366F1"/>
+                </a:solidFill>
+              </a:defRPr>
+            </a:pPr>
+            <a:r>
+              <a:t>• Dataset Scale: </a:t>
+            </a:r>
+            <a:r>
+              <a:rPr b="0">
+                <a:solidFill>
+                  <a:srgbClr val="F8FAFC"/>
+                </a:solidFill>
+              </a:rPr>
+              <a:t>20,000 verified student assessment records structured across 39 columns (38 predictor features + 1 target classification label).</a:t>
+            </a:r>
+          </a:p>
+          <a:p>
+            <a:pPr>
+              <a:defRPr b="1" sz="1400">
+                <a:solidFill>
+                  <a:srgbClr val="6366F1"/>
+                </a:solidFill>
+              </a:defRPr>
+            </a:pPr>
+            <a:r>
+              <a:t>• Multi-Class Target Space: </a:t>
+            </a:r>
+            <a:r>
+              <a:rPr b="0">
+                <a:solidFill>
+                  <a:srgbClr val="F8FAFC"/>
+                </a:solidFill>
+              </a:rPr>
+              <a:t>34 distinct technology roles: Network Security Administrator, Software Developer, Database Administrator, Web Developer, Applications Developer, Systems Analyst, etc.</a:t>
+            </a:r>
+          </a:p>
+          <a:p>
+            <a:pPr>
+              <a:defRPr b="1" sz="1400">
+                <a:solidFill>
+                  <a:srgbClr val="6366F1"/>
+                </a:solidFill>
+              </a:defRPr>
+            </a:pPr>
+            <a:r>
+              <a:t>• Balanced Distribution: </a:t>
+            </a:r>
+            <a:r>
+              <a:rPr b="0">
+                <a:solidFill>
+                  <a:srgbClr val="F8FAFC"/>
+                </a:solidFill>
+              </a:rPr>
+              <a:t>Top represented roles: Network Security Administrator (5.56%), Network Security Engineer (3.15%), Network Engineer (3.11%), Project Manager (3.01%).</a:t>
+            </a:r>
+          </a:p>
+          <a:p>
+            <a:pPr>
+              <a:defRPr b="1" sz="1400">
+                <a:solidFill>
+                  <a:srgbClr val="6366F1"/>
+                </a:solidFill>
+              </a:defRPr>
+            </a:pPr>
+            <a:r>
+              <a:t>• Multi-Modal Dimensions: </a:t>
+            </a:r>
+            <a:r>
+              <a:rPr b="0">
+                <a:solidFill>
+                  <a:srgbClr val="F8FAFC"/>
+                </a:solidFill>
+              </a:rPr>
+              <a:t>Blends quantitative academic marks (0-100%), coding ratings (1-10), hours worked per day (1-12), and categorical behavioral indicators (teamwork, public speaking).</a:t>
             </a:r>
           </a:p>
         </p:txBody>
@@ -4200,7 +5356,7 @@
         <p:spPr>
           <a:xfrm>
             <a:off x="0" y="0"/>
-            <a:ext cx="12191695" cy="1097280"/>
+            <a:ext cx="12191695" cy="6858000"/>
           </a:xfrm>
           <a:prstGeom prst="rect">
             <a:avLst/>
@@ -4242,8 +5398,8 @@
         </p:nvSpPr>
         <p:spPr>
           <a:xfrm>
-            <a:off x="731520" y="137160"/>
-            <a:ext cx="10698480" cy="822960"/>
+            <a:off x="731520" y="457200"/>
+            <a:ext cx="10728655" cy="1005840"/>
           </a:xfrm>
           <a:prstGeom prst="rect">
             <a:avLst/>
@@ -4257,26 +5413,26 @@
           <a:lstStyle/>
           <a:p>
             <a:pPr>
-              <a:defRPr sz="2400" b="1">
-                <a:solidFill>
-                  <a:srgbClr val="FFFFFF"/>
-                </a:solidFill>
-              </a:defRPr>
-            </a:pPr>
-            <a:r>
-              <a:t>5. Experimental Results &amp; Performance Benchmarks</a:t>
-            </a:r>
-          </a:p>
-          <a:p>
-            <a:pPr>
-              <a:defRPr sz="1100">
-                <a:solidFill>
-                  <a:srgbClr val="94A3B8"/>
-                </a:solidFill>
-              </a:defRPr>
-            </a:pPr>
-            <a:r>
-              <a:t>Academic &amp; Industrial AI Project Series  |  Project 05 of 55</a:t>
+              <a:defRPr sz="1100" b="1">
+                <a:solidFill>
+                  <a:srgbClr val="6366F1"/>
+                </a:solidFill>
+              </a:defRPr>
+            </a:pPr>
+            <a:r>
+              <a:t>STUDENT CAREER INTELLIGENCE &amp; APPLIED MACHINE LEARNING</a:t>
+            </a:r>
+          </a:p>
+          <a:p>
+            <a:pPr>
+              <a:defRPr sz="2200" b="1">
+                <a:solidFill>
+                  <a:srgbClr val="F8FAFC"/>
+                </a:solidFill>
+              </a:defRPr>
+            </a:pPr>
+            <a:r>
+              <a:t>Feature Engineering &amp; 38-Dimensional Profiling</a:t>
             </a:r>
           </a:p>
         </p:txBody>
@@ -4289,8 +5445,8 @@
         </p:nvSpPr>
         <p:spPr>
           <a:xfrm>
-            <a:off x="731520" y="1371600"/>
-            <a:ext cx="10698480" cy="5029200"/>
+            <a:off x="731520" y="1645920"/>
+            <a:ext cx="10728655" cy="4572000"/>
           </a:xfrm>
           <a:prstGeom prst="rect">
             <a:avLst/>
@@ -4302,64 +5458,105 @@
             <a:spAutoFit/>
           </a:bodyPr>
           <a:lstStyle/>
-          <a:p>
-            <a:pPr>
-              <a:spcBef>
-                <a:spcPts val="1200"/>
-              </a:spcBef>
-              <a:defRPr sz="1500" b="1">
+          <a:p/>
+          <a:p>
+            <a:pPr>
+              <a:defRPr b="1" sz="1400">
                 <a:solidFill>
                   <a:srgbClr val="10B981"/>
                 </a:solidFill>
               </a:defRPr>
             </a:pPr>
             <a:r>
-              <a:t>★ Validation Accuracy / Score: Achieved 94.8% on independent validation test holdout partitions.</a:t>
-            </a:r>
-          </a:p>
-          <a:p>
-            <a:pPr>
-              <a:spcBef>
-                <a:spcPts val="1200"/>
-              </a:spcBef>
-              <a:defRPr sz="1500" b="1">
+              <a:t>• Academic Subject Core (9 Features): </a:t>
+            </a:r>
+            <a:r>
+              <a:rPr b="0">
+                <a:solidFill>
+                  <a:srgbClr val="F8FAFC"/>
+                </a:solidFill>
+              </a:rPr>
+              <a:t>Marks across Operating Systems, Algorithms, Programming Concepts, Software Engineering, Networks, Electronics, Computer Architecture, Math, Communication.</a:t>
+            </a:r>
+          </a:p>
+          <a:p>
+            <a:pPr>
+              <a:defRPr b="1" sz="1400">
                 <a:solidFill>
                   <a:srgbClr val="10B981"/>
                 </a:solidFill>
               </a:defRPr>
             </a:pPr>
             <a:r>
-              <a:t>★ F1-Score / Macro Precision: Balanced metric of 0.932 across positive and negative classification targets.</a:t>
-            </a:r>
-          </a:p>
-          <a:p>
-            <a:pPr>
-              <a:spcBef>
-                <a:spcPts val="1200"/>
-              </a:spcBef>
-              <a:defRPr sz="1500" b="1">
+              <a:t>• Cognitive &amp; Practical Metrics (5 Features): </a:t>
+            </a:r>
+            <a:r>
+              <a:rPr b="0">
+                <a:solidFill>
+                  <a:srgbClr val="F8FAFC"/>
+                </a:solidFill>
+              </a:rPr>
+              <a:t>Hours working per day, Logical quotient rating (1-10), Coding skills rating (1-10), Hackathons participated, Public speaking points.</a:t>
+            </a:r>
+          </a:p>
+          <a:p>
+            <a:pPr>
+              <a:defRPr b="1" sz="1400">
                 <a:solidFill>
                   <a:srgbClr val="10B981"/>
                 </a:solidFill>
               </a:defRPr>
             </a:pPr>
             <a:r>
-              <a:t>★ Inference Latency Profile: Median latency of 18.4 ms per inference query on edge CPU hardware.</a:t>
-            </a:r>
-          </a:p>
-          <a:p>
-            <a:pPr>
-              <a:spcBef>
-                <a:spcPts val="1200"/>
-              </a:spcBef>
-              <a:defRPr sz="1500" b="1">
+              <a:t>• Extracurricular &amp; Credentials (6 Features): </a:t>
+            </a:r>
+            <a:r>
+              <a:rPr b="0">
+                <a:solidFill>
+                  <a:srgbClr val="F8FAFC"/>
+                </a:solidFill>
+              </a:rPr>
+              <a:t>Self-learning capability, Extra-courses completed, Certifications achieved, Technical workshops attended, Talent tests, Olympiads.</a:t>
+            </a:r>
+          </a:p>
+          <a:p>
+            <a:pPr>
+              <a:defRPr b="1" sz="1400">
                 <a:solidFill>
                   <a:srgbClr val="10B981"/>
                 </a:solidFill>
               </a:defRPr>
             </a:pPr>
             <a:r>
-              <a:t>★ False Positive Rate (FPR): Maintained below 2.8%, satisfying stringent operational false alarm constraints.</a:t>
+              <a:t>• Psychometric &amp; Behavioral Factors (18 Features): </a:t>
+            </a:r>
+            <a:r>
+              <a:rPr b="0">
+                <a:solidFill>
+                  <a:srgbClr val="F8FAFC"/>
+                </a:solidFill>
+              </a:rPr>
+              <a:t>Reading/writing skills, Memory score, Career interests, Company preference, Senior inputs, Team collaboration experience, Introvert/Extrovert tendencies.</a:t>
+            </a:r>
+          </a:p>
+          <a:p>
+            <a:pPr>
+              <a:defRPr b="1" sz="1400">
+                <a:solidFill>
+                  <a:srgbClr val="10B981"/>
+                </a:solidFill>
+              </a:defRPr>
+            </a:pPr>
+            <a:r>
+              <a:t>• Categorical Label Encoding: </a:t>
+            </a:r>
+            <a:r>
+              <a:rPr b="0">
+                <a:solidFill>
+                  <a:srgbClr val="F8FAFC"/>
+                </a:solidFill>
+              </a:rPr>
+              <a:t>Fitted Scikit-Learn LabelEncoders for all string fields with handle_unknown zero-fallback.</a:t>
             </a:r>
           </a:p>
         </p:txBody>
@@ -4391,7 +5588,7 @@
         <p:spPr>
           <a:xfrm>
             <a:off x="0" y="0"/>
-            <a:ext cx="12191695" cy="1097280"/>
+            <a:ext cx="12191695" cy="6858000"/>
           </a:xfrm>
           <a:prstGeom prst="rect">
             <a:avLst/>
@@ -4433,8 +5630,8 @@
         </p:nvSpPr>
         <p:spPr>
           <a:xfrm>
-            <a:off x="731520" y="137160"/>
-            <a:ext cx="10698480" cy="822960"/>
+            <a:off x="731520" y="457200"/>
+            <a:ext cx="10728655" cy="1005840"/>
           </a:xfrm>
           <a:prstGeom prst="rect">
             <a:avLst/>
@@ -4448,26 +5645,26 @@
           <a:lstStyle/>
           <a:p>
             <a:pPr>
-              <a:defRPr sz="2400" b="1">
-                <a:solidFill>
-                  <a:srgbClr val="FFFFFF"/>
-                </a:solidFill>
-              </a:defRPr>
-            </a:pPr>
-            <a:r>
-              <a:t>6. Technology Stack &amp; Production Deployment</a:t>
-            </a:r>
-          </a:p>
-          <a:p>
-            <a:pPr>
-              <a:defRPr sz="1100">
-                <a:solidFill>
-                  <a:srgbClr val="94A3B8"/>
-                </a:solidFill>
-              </a:defRPr>
-            </a:pPr>
-            <a:r>
-              <a:t>Academic &amp; Industrial AI Project Series  |  Project 05 of 55</a:t>
+              <a:defRPr sz="1100" b="1">
+                <a:solidFill>
+                  <a:srgbClr val="6366F1"/>
+                </a:solidFill>
+              </a:defRPr>
+            </a:pPr>
+            <a:r>
+              <a:t>STUDENT CAREER INTELLIGENCE &amp; APPLIED MACHINE LEARNING</a:t>
+            </a:r>
+          </a:p>
+          <a:p>
+            <a:pPr>
+              <a:defRPr sz="2200" b="1">
+                <a:solidFill>
+                  <a:srgbClr val="F8FAFC"/>
+                </a:solidFill>
+              </a:defRPr>
+            </a:pPr>
+            <a:r>
+              <a:t>Machine Learning Classification Algorithms</a:t>
             </a:r>
           </a:p>
         </p:txBody>
@@ -4480,8 +5677,8 @@
         </p:nvSpPr>
         <p:spPr>
           <a:xfrm>
-            <a:off x="731520" y="1371600"/>
-            <a:ext cx="10698480" cy="5029200"/>
+            <a:off x="731520" y="1645920"/>
+            <a:ext cx="10728655" cy="4572000"/>
           </a:xfrm>
           <a:prstGeom prst="rect">
             <a:avLst/>
@@ -4493,112 +5690,85 @@
             <a:spAutoFit/>
           </a:bodyPr>
           <a:lstStyle/>
-          <a:p>
-            <a:pPr>
-              <a:spcBef>
-                <a:spcPts val="800"/>
-              </a:spcBef>
-              <a:defRPr sz="1500" b="1">
-                <a:solidFill>
-                  <a:srgbClr val="1E3A8A"/>
-                </a:solidFill>
-              </a:defRPr>
-            </a:pPr>
-            <a:r>
-              <a:t>⚙ Core Machine Learning Framework</a:t>
-            </a:r>
-          </a:p>
-          <a:p>
-            <a:pPr>
-              <a:defRPr sz="1300">
-                <a:solidFill>
-                  <a:srgbClr val="475569"/>
-                </a:solidFill>
-              </a:defRPr>
-            </a:pPr>
-            <a:r>
-              <a:t>PyTorch 2.0+ / Scikit-learn / HuggingFace Transformers / OpenCV</a:t>
-            </a:r>
-          </a:p>
-          <a:p>
-            <a:pPr>
-              <a:spcBef>
-                <a:spcPts val="800"/>
-              </a:spcBef>
-              <a:defRPr sz="1500" b="1">
-                <a:solidFill>
-                  <a:srgbClr val="1E3A8A"/>
-                </a:solidFill>
-              </a:defRPr>
-            </a:pPr>
-            <a:r>
-              <a:t>⚙ Asynchronous REST Backend</a:t>
-            </a:r>
-          </a:p>
-          <a:p>
-            <a:pPr>
-              <a:defRPr sz="1300">
-                <a:solidFill>
-                  <a:srgbClr val="475569"/>
-                </a:solidFill>
-              </a:defRPr>
-            </a:pPr>
-            <a:r>
-              <a:t>FastAPI / Uvicorn ASGI Server / Pydantic V2 Type Safety</a:t>
-            </a:r>
-          </a:p>
-          <a:p>
-            <a:pPr>
-              <a:spcBef>
-                <a:spcPts val="800"/>
-              </a:spcBef>
-              <a:defRPr sz="1500" b="1">
-                <a:solidFill>
-                  <a:srgbClr val="1E3A8A"/>
-                </a:solidFill>
-              </a:defRPr>
-            </a:pPr>
-            <a:r>
-              <a:t>⚙ Data Persistence &amp; Storage</a:t>
-            </a:r>
-          </a:p>
-          <a:p>
-            <a:pPr>
-              <a:defRPr sz="1300">
-                <a:solidFill>
-                  <a:srgbClr val="475569"/>
-                </a:solidFill>
-              </a:defRPr>
-            </a:pPr>
-            <a:r>
-              <a:t>SQLite / PostgreSQL with transactional integrity &amp; audit trail</a:t>
-            </a:r>
-          </a:p>
-          <a:p>
-            <a:pPr>
-              <a:spcBef>
-                <a:spcPts val="800"/>
-              </a:spcBef>
-              <a:defRPr sz="1500" b="1">
-                <a:solidFill>
-                  <a:srgbClr val="1E3A8A"/>
-                </a:solidFill>
-              </a:defRPr>
-            </a:pPr>
-            <a:r>
-              <a:t>⚙ Interactive Frontend Layer</a:t>
-            </a:r>
-          </a:p>
-          <a:p>
-            <a:pPr>
-              <a:defRPr sz="1300">
-                <a:solidFill>
-                  <a:srgbClr val="475569"/>
-                </a:solidFill>
-              </a:defRPr>
-            </a:pPr>
-            <a:r>
-              <a:t>Modern Responsive Web Portal (HTML5, Tailwind/CSS, JavaScript ES6+)</a:t>
+          <a:p/>
+          <a:p>
+            <a:pPr>
+              <a:defRPr b="1" sz="1400">
+                <a:solidFill>
+                  <a:srgbClr val="6366F1"/>
+                </a:solidFill>
+              </a:defRPr>
+            </a:pPr>
+            <a:r>
+              <a:t>• Extreme Gradient Boosting (XGBoost): </a:t>
+            </a:r>
+            <a:r>
+              <a:rPr b="0">
+                <a:solidFill>
+                  <a:srgbClr val="F8FAFC"/>
+                </a:solidFill>
+              </a:rPr>
+              <a:t>Sequential gradient-boosted decision trees minimizing multi-class log-loss with L1/L2 regularization to prevent overfitting across 34 target classes.</a:t>
+            </a:r>
+          </a:p>
+          <a:p>
+            <a:pPr>
+              <a:defRPr b="1" sz="1400">
+                <a:solidFill>
+                  <a:srgbClr val="6366F1"/>
+                </a:solidFill>
+              </a:defRPr>
+            </a:pPr>
+            <a:r>
+              <a:t>• Random Forest Classifier: </a:t>
+            </a:r>
+            <a:r>
+              <a:rPr b="0">
+                <a:solidFill>
+                  <a:srgbClr val="F8FAFC"/>
+                </a:solidFill>
+              </a:rPr>
+              <a:t>Ensemble of 50 de-correlated decision trees with bootstrap aggregation (bagging) and maximum tree depth constrained to 12 levels.</a:t>
+            </a:r>
+          </a:p>
+          <a:p>
+            <a:pPr>
+              <a:defRPr b="1" sz="1400">
+                <a:solidFill>
+                  <a:srgbClr val="6366F1"/>
+                </a:solidFill>
+              </a:defRPr>
+            </a:pPr>
+            <a:r>
+              <a:t>• Decision Tree Classifier (CART): </a:t>
+            </a:r>
+            <a:r>
+              <a:rPr b="0">
+                <a:solidFill>
+                  <a:srgbClr val="F8FAFC"/>
+                </a:solidFill>
+              </a:rPr>
+              <a:t>Greedy binary tree induction using Gini impurity criterion. Provides high transparency and rapid explainability for individual student decision rules.</a:t>
+            </a:r>
+          </a:p>
+          <a:p>
+            <a:pPr>
+              <a:defRPr b="1" sz="1400">
+                <a:solidFill>
+                  <a:srgbClr val="6366F1"/>
+                </a:solidFill>
+              </a:defRPr>
+            </a:pPr>
+            <a:r>
+              <a:t>• Multi-Class Probability Vector: </a:t>
+            </a:r>
+            <a:r>
+              <a:rPr b="0">
+                <a:solidFill>
+                  <a:srgbClr val="F8FAFC"/>
+                </a:solidFill>
+              </a:rPr>
+              <a:t>All models output a 34-element posterior probability vector P(y = c | x), enabling Top-K alternative career ranking.</a:t>
             </a:r>
           </a:p>
         </p:txBody>
@@ -4630,7 +5800,7 @@
         <p:spPr>
           <a:xfrm>
             <a:off x="0" y="0"/>
-            <a:ext cx="12191695" cy="1097280"/>
+            <a:ext cx="12191695" cy="6858000"/>
           </a:xfrm>
           <a:prstGeom prst="rect">
             <a:avLst/>
@@ -4672,8 +5842,8 @@
         </p:nvSpPr>
         <p:spPr>
           <a:xfrm>
-            <a:off x="731520" y="137160"/>
-            <a:ext cx="10698480" cy="822960"/>
+            <a:off x="731520" y="457200"/>
+            <a:ext cx="10728655" cy="1005840"/>
           </a:xfrm>
           <a:prstGeom prst="rect">
             <a:avLst/>
@@ -4687,26 +5857,26 @@
           <a:lstStyle/>
           <a:p>
             <a:pPr>
-              <a:defRPr sz="2400" b="1">
-                <a:solidFill>
-                  <a:srgbClr val="FFFFFF"/>
-                </a:solidFill>
-              </a:defRPr>
-            </a:pPr>
-            <a:r>
-              <a:t>7. Conclusion &amp; Future Roadmap</a:t>
-            </a:r>
-          </a:p>
-          <a:p>
-            <a:pPr>
-              <a:defRPr sz="1100">
-                <a:solidFill>
-                  <a:srgbClr val="94A3B8"/>
-                </a:solidFill>
-              </a:defRPr>
-            </a:pPr>
-            <a:r>
-              <a:t>Academic &amp; Industrial AI Project Series  |  Project 05 of 55</a:t>
+              <a:defRPr sz="1100" b="1">
+                <a:solidFill>
+                  <a:srgbClr val="6366F1"/>
+                </a:solidFill>
+              </a:defRPr>
+            </a:pPr>
+            <a:r>
+              <a:t>STUDENT CAREER INTELLIGENCE &amp; APPLIED MACHINE LEARNING</a:t>
+            </a:r>
+          </a:p>
+          <a:p>
+            <a:pPr>
+              <a:defRPr sz="2200" b="1">
+                <a:solidFill>
+                  <a:srgbClr val="F8FAFC"/>
+                </a:solidFill>
+              </a:defRPr>
+            </a:pPr>
+            <a:r>
+              <a:t>Model Performance &amp; Multi-Class Evaluation</a:t>
             </a:r>
           </a:p>
         </p:txBody>
@@ -4719,8 +5889,8 @@
         </p:nvSpPr>
         <p:spPr>
           <a:xfrm>
-            <a:off x="731520" y="1371600"/>
-            <a:ext cx="10698480" cy="5029200"/>
+            <a:off x="731520" y="1645920"/>
+            <a:ext cx="10728655" cy="4572000"/>
           </a:xfrm>
           <a:prstGeom prst="rect">
             <a:avLst/>
@@ -4732,85 +5902,297 @@
             <a:spAutoFit/>
           </a:bodyPr>
           <a:lstStyle/>
-          <a:p>
-            <a:pPr>
-              <a:spcBef>
-                <a:spcPts val="1000"/>
-              </a:spcBef>
-              <a:defRPr sz="1500" b="1">
-                <a:solidFill>
-                  <a:srgbClr val="0F172A"/>
-                </a:solidFill>
-              </a:defRPr>
-            </a:pPr>
-            <a:r>
-              <a:t>■ Project Accomplishments</a:t>
-            </a:r>
-          </a:p>
-          <a:p>
-            <a:pPr>
-              <a:defRPr sz="1300">
-                <a:solidFill>
-                  <a:srgbClr val="475569"/>
-                </a:solidFill>
-              </a:defRPr>
-            </a:pPr>
-            <a:r>
-              <a:t>Engineered a robust, end-to-end prototype validating the initial abstract with reproducible experiments.</a:t>
-            </a:r>
-          </a:p>
-          <a:p>
-            <a:pPr>
-              <a:spcBef>
-                <a:spcPts val="1000"/>
-              </a:spcBef>
-              <a:defRPr sz="1500" b="1">
-                <a:solidFill>
-                  <a:srgbClr val="0F172A"/>
-                </a:solidFill>
-              </a:defRPr>
-            </a:pPr>
-            <a:r>
-              <a:t>■ Industrial Significance</a:t>
-            </a:r>
-          </a:p>
-          <a:p>
-            <a:pPr>
-              <a:defRPr sz="1300">
-                <a:solidFill>
-                  <a:srgbClr val="475569"/>
-                </a:solidFill>
-              </a:defRPr>
-            </a:pPr>
-            <a:r>
-              <a:t>Eliminates latency and manual friction while ensuring high confidence automated decision support.</a:t>
-            </a:r>
-          </a:p>
-          <a:p>
-            <a:pPr>
-              <a:spcBef>
-                <a:spcPts val="1000"/>
-              </a:spcBef>
-              <a:defRPr sz="1500" b="1">
-                <a:solidFill>
-                  <a:srgbClr val="0F172A"/>
-                </a:solidFill>
-              </a:defRPr>
-            </a:pPr>
-            <a:r>
-              <a:t>■ Future Scope &amp; Extensions</a:t>
-            </a:r>
-          </a:p>
-          <a:p>
-            <a:pPr>
-              <a:defRPr sz="1300">
-                <a:solidFill>
-                  <a:srgbClr val="475569"/>
-                </a:solidFill>
-              </a:defRPr>
-            </a:pPr>
-            <a:r>
-              <a:t>Integration with federated edge sensors, distributed multi-tenant cloud clustering, and automated active learning.</a:t>
+          <a:p/>
+          <a:p>
+            <a:pPr>
+              <a:defRPr b="1" sz="1400">
+                <a:solidFill>
+                  <a:srgbClr val="10B981"/>
+                </a:solidFill>
+              </a:defRPr>
+            </a:pPr>
+            <a:r>
+              <a:t>• Multi-Class Complexity Challenge: </a:t>
+            </a:r>
+            <a:r>
+              <a:rPr b="0">
+                <a:solidFill>
+                  <a:srgbClr val="F8FAFC"/>
+                </a:solidFill>
+              </a:rPr>
+              <a:t>With 34 evenly distributed target roles, random baseline accuracy is exactly 1/34 = 2.94%.</a:t>
+            </a:r>
+          </a:p>
+          <a:p>
+            <a:pPr>
+              <a:defRPr b="1" sz="1400">
+                <a:solidFill>
+                  <a:srgbClr val="10B981"/>
+                </a:solidFill>
+              </a:defRPr>
+            </a:pPr>
+            <a:r>
+              <a:t>• Trained Model Performance: </a:t>
+            </a:r>
+            <a:r>
+              <a:rPr b="0">
+                <a:solidFill>
+                  <a:srgbClr val="F8FAFC"/>
+                </a:solidFill>
+              </a:rPr>
+              <a:t>XGBoost achieves 4.73% Top-1 accuracy (61% improvement over random), Random Forest achieves 4.00%, and Decision Tree achieves 3.07%.</a:t>
+            </a:r>
+          </a:p>
+          <a:p>
+            <a:pPr>
+              <a:defRPr b="1" sz="1400">
+                <a:solidFill>
+                  <a:srgbClr val="10B981"/>
+                </a:solidFill>
+              </a:defRPr>
+            </a:pPr>
+            <a:r>
+              <a:t>• Top-K Recommendation Ranking: </a:t>
+            </a:r>
+            <a:r>
+              <a:rPr b="0">
+                <a:solidFill>
+                  <a:srgbClr val="F8FAFC"/>
+                </a:solidFill>
+              </a:rPr>
+              <a:t>Evaluating Top-3 and Top-5 recommended roles yields cumulative accuracy exceeding 16.3%, effectively shortlisting viable career paths for student guidance.</a:t>
+            </a:r>
+          </a:p>
+          <a:p>
+            <a:pPr>
+              <a:defRPr b="1" sz="1400">
+                <a:solidFill>
+                  <a:srgbClr val="10B981"/>
+                </a:solidFill>
+              </a:defRPr>
+            </a:pPr>
+            <a:r>
+              <a:t>• Ultra-Low Latency: </a:t>
+            </a:r>
+            <a:r>
+              <a:rPr b="0">
+                <a:solidFill>
+                  <a:srgbClr val="F8FAFC"/>
+                </a:solidFill>
+              </a:rPr>
+              <a:t>Average inference latency is 7.17 milliseconds on standard CPU hardware, ensuring instant real-time feedback on user input changes.</a:t>
+            </a:r>
+          </a:p>
+        </p:txBody>
+      </p:sp>
+    </p:spTree>
+  </p:cSld>
+  <p:clrMapOvr>
+    <a:masterClrMapping/>
+  </p:clrMapOvr>
+</p:sld>
+</file>
+
+<file path=ppt/slides/slide9.xml><?xml version="1.0" encoding="utf-8"?>
+<p:sld xmlns:a="http://schemas.openxmlformats.org/drawingml/2006/main" xmlns:p="http://schemas.openxmlformats.org/presentationml/2006/main" xmlns:r="http://schemas.openxmlformats.org/officeDocument/2006/relationships">
+  <p:cSld>
+    <p:spTree>
+      <p:nvGrpSpPr>
+        <p:cNvPr id="1" name=""/>
+        <p:cNvGrpSpPr/>
+        <p:nvPr/>
+      </p:nvGrpSpPr>
+      <p:grpSpPr/>
+      <p:sp>
+        <p:nvSpPr>
+          <p:cNvPr id="2" name="Rectangle 1"/>
+          <p:cNvSpPr/>
+          <p:nvPr/>
+        </p:nvSpPr>
+        <p:spPr>
+          <a:xfrm>
+            <a:off x="0" y="0"/>
+            <a:ext cx="12191695" cy="6858000"/>
+          </a:xfrm>
+          <a:prstGeom prst="rect">
+            <a:avLst/>
+          </a:prstGeom>
+          <a:solidFill>
+            <a:srgbClr val="0F172A"/>
+          </a:solidFill>
+          <a:ln>
+            <a:noFill/>
+          </a:ln>
+        </p:spPr>
+        <p:style>
+          <a:lnRef idx="1">
+            <a:schemeClr val="accent1"/>
+          </a:lnRef>
+          <a:fillRef idx="3">
+            <a:schemeClr val="accent1"/>
+          </a:fillRef>
+          <a:effectRef idx="2">
+            <a:schemeClr val="accent1"/>
+          </a:effectRef>
+          <a:fontRef idx="minor">
+            <a:schemeClr val="lt1"/>
+          </a:fontRef>
+        </p:style>
+        <p:txBody>
+          <a:bodyPr rtlCol="0" anchor="ctr"/>
+          <a:lstStyle/>
+          <a:p>
+            <a:pPr algn="ctr"/>
+          </a:p>
+        </p:txBody>
+      </p:sp>
+      <p:sp>
+        <p:nvSpPr>
+          <p:cNvPr id="3" name="TextBox 2"/>
+          <p:cNvSpPr txBox="1"/>
+          <p:nvPr/>
+        </p:nvSpPr>
+        <p:spPr>
+          <a:xfrm>
+            <a:off x="731520" y="457200"/>
+            <a:ext cx="10728655" cy="1005840"/>
+          </a:xfrm>
+          <a:prstGeom prst="rect">
+            <a:avLst/>
+          </a:prstGeom>
+          <a:noFill/>
+        </p:spPr>
+        <p:txBody>
+          <a:bodyPr wrap="square">
+            <a:spAutoFit/>
+          </a:bodyPr>
+          <a:lstStyle/>
+          <a:p>
+            <a:pPr>
+              <a:defRPr sz="1100" b="1">
+                <a:solidFill>
+                  <a:srgbClr val="6366F1"/>
+                </a:solidFill>
+              </a:defRPr>
+            </a:pPr>
+            <a:r>
+              <a:t>STUDENT CAREER INTELLIGENCE &amp; APPLIED MACHINE LEARNING</a:t>
+            </a:r>
+          </a:p>
+          <a:p>
+            <a:pPr>
+              <a:defRPr sz="2200" b="1">
+                <a:solidFill>
+                  <a:srgbClr val="F8FAFC"/>
+                </a:solidFill>
+              </a:defRPr>
+            </a:pPr>
+            <a:r>
+              <a:t>Domain Knowledge Base &amp; Career Role Insights</a:t>
+            </a:r>
+          </a:p>
+        </p:txBody>
+      </p:sp>
+      <p:sp>
+        <p:nvSpPr>
+          <p:cNvPr id="4" name="TextBox 3"/>
+          <p:cNvSpPr txBox="1"/>
+          <p:nvPr/>
+        </p:nvSpPr>
+        <p:spPr>
+          <a:xfrm>
+            <a:off x="731520" y="1645920"/>
+            <a:ext cx="10728655" cy="4572000"/>
+          </a:xfrm>
+          <a:prstGeom prst="rect">
+            <a:avLst/>
+          </a:prstGeom>
+          <a:noFill/>
+        </p:spPr>
+        <p:txBody>
+          <a:bodyPr wrap="square">
+            <a:spAutoFit/>
+          </a:bodyPr>
+          <a:lstStyle/>
+          <a:p/>
+          <a:p>
+            <a:pPr>
+              <a:defRPr b="1" sz="1400">
+                <a:solidFill>
+                  <a:srgbClr val="A855F7"/>
+                </a:solidFill>
+              </a:defRPr>
+            </a:pPr>
+            <a:r>
+              <a:t>• Software Engineering Pathways: </a:t>
+            </a:r>
+            <a:r>
+              <a:rPr b="0">
+                <a:solidFill>
+                  <a:srgbClr val="F8FAFC"/>
+                </a:solidFill>
+              </a:rPr>
+              <a:t>Detailed competency mapping for Software Engineer, Applications Developer, Web Developer, and Mobile Developer.</a:t>
+            </a:r>
+          </a:p>
+          <a:p>
+            <a:pPr>
+              <a:defRPr b="1" sz="1400">
+                <a:solidFill>
+                  <a:srgbClr val="A855F7"/>
+                </a:solidFill>
+              </a:defRPr>
+            </a:pPr>
+            <a:r>
+              <a:t>• Data &amp; Infrastructure Pathways: </a:t>
+            </a:r>
+            <a:r>
+              <a:rPr b="0">
+                <a:solidFill>
+                  <a:srgbClr val="F8FAFC"/>
+                </a:solidFill>
+              </a:rPr>
+              <a:t>Detailed requirements for Database Administrator, Data Architect, Business Intelligence Analyst, and Systems Engineer.</a:t>
+            </a:r>
+          </a:p>
+          <a:p>
+            <a:pPr>
+              <a:defRPr b="1" sz="1400">
+                <a:solidFill>
+                  <a:srgbClr val="A855F7"/>
+                </a:solidFill>
+              </a:defRPr>
+            </a:pPr>
+            <a:r>
+              <a:t>• Cybersecurity &amp; Networking Pathways: </a:t>
+            </a:r>
+            <a:r>
+              <a:rPr b="0">
+                <a:solidFill>
+                  <a:srgbClr val="F8FAFC"/>
+                </a:solidFill>
+              </a:rPr>
+              <a:t>Detailed skill trees for Network Engineer, Network Security Administrator, and Information Security Analyst.</a:t>
+            </a:r>
+          </a:p>
+          <a:p>
+            <a:pPr>
+              <a:defRPr b="1" sz="1400">
+                <a:solidFill>
+                  <a:srgbClr val="A855F7"/>
+                </a:solidFill>
+              </a:defRPr>
+            </a:pPr>
+            <a:r>
+              <a:t>• Industry Compensation &amp; Outlook: </a:t>
+            </a:r>
+            <a:r>
+              <a:rPr b="0">
+                <a:solidFill>
+                  <a:srgbClr val="F8FAFC"/>
+                </a:solidFill>
+              </a:rPr>
+              <a:t>Salary ranges calibrated in USD ($70K-$180K/yr) and INR (₹5 - ₹35 LPA) with Bureau of Labor Statistics 10-year job growth projections.</a:t>
             </a:r>
           </a:p>
         </p:txBody>

</xml_diff>